<commit_message>
Enhance PowerPoint processing and documentation
- Updated `.gitignore` to exclude additional files.
- Improved `README.md` with new feature descriptions and examples.
- Modified `Directory.Build.props` for project rebranding.
- Introduced new classes for logging, data binding, and expression adjustment in `DataBinder.cs`, `ExpressionAdjuster.cs`, and others.
- Added `PPTMethods.cs` for PowerPoint-specific operations.
- Enhanced `SlideManager.cs` for better slide note management.
- Implemented directive parsing in `DirectiveProcessor.cs` and `Directives.cs`.
- Updated project files to include new dependencies and global usings.
- Refactored and improved various model files to support new features.
- Added utility methods in `StringExtensions.cs`, `ElementExtensions.cs`, and `SlideExtensions.cs`.
- Introduced new tests for nested syntax and improved existing tests for robustness.
- Removed obsolete files and updated documentation for clarity.
</commit_message>
<xml_diff>
--- a/src/DocuChef.TestConsoleApp/files/ppt/nested_template.pptx
+++ b/src/DocuChef.TestConsoleApp/files/ppt/nested_template.pptx
@@ -5,12 +5,11 @@
     <p:sldMasterId id="2147483648" r:id="rId1"/>
   </p:sldMasterIdLst>
   <p:notesMasterIdLst>
-    <p:notesMasterId r:id="rId5"/>
+    <p:notesMasterId r:id="rId4"/>
   </p:notesMasterIdLst>
   <p:sldIdLst>
     <p:sldId id="256" r:id="rId2"/>
     <p:sldId id="257" r:id="rId3"/>
-    <p:sldId id="258" r:id="rId4"/>
   </p:sldIdLst>
   <p:sldSz cx="12192000" cy="6858000"/>
   <p:notesSz cx="6858000" cy="9144000"/>
@@ -109,6 +108,11 @@
       </a:defRPr>
     </a:lvl9pPr>
   </p:defaultTextStyle>
+  <p:extLst>
+    <p:ext uri="{EFAFB233-063F-42B5-8137-9DF3F51BA10A}">
+      <p15:sldGuideLst xmlns:p15="http://schemas.microsoft.com/office/powerpoint/2012/main"/>
+    </p:ext>
+  </p:extLst>
 </p:presentation>
 </file>
 
@@ -192,9 +196,9 @@
             </a:lvl1pPr>
           </a:lstStyle>
           <a:p>
-            <a:fld id="{36A13D49-3A11-4D46-AAFA-79B8554F2C09}" type="datetimeFigureOut">
+            <a:fld id="{C9BA1C13-EB90-434E-A9A2-4BE8962BA80B}" type="datetimeFigureOut">
               <a:rPr lang="ko-KR" altLang="en-US" smtClean="0"/>
-              <a:t>2025-05-15</a:t>
+              <a:t>2025-05-21</a:t>
             </a:fld>
             <a:endParaRPr lang="ko-KR" altLang="en-US"/>
           </a:p>
@@ -350,7 +354,7 @@
             </a:lvl1pPr>
           </a:lstStyle>
           <a:p>
-            <a:fld id="{E0BE65D6-FC4B-4387-9677-FDDBE5B571BA}" type="slidenum">
+            <a:fld id="{1CE3E641-4F17-435E-BCD6-616AEBF8C0F0}" type="slidenum">
               <a:rPr lang="ko-KR" altLang="en-US" smtClean="0"/>
               <a:t>‹#›</a:t>
             </a:fld>
@@ -361,7 +365,7 @@
     </p:spTree>
     <p:extLst>
       <p:ext uri="{BB962C8B-B14F-4D97-AF65-F5344CB8AC3E}">
-        <p14:creationId xmlns:p14="http://schemas.microsoft.com/office/powerpoint/2010/main" val="2611234007"/>
+        <p14:creationId xmlns:p14="http://schemas.microsoft.com/office/powerpoint/2010/main" val="3187989614"/>
       </p:ext>
     </p:extLst>
   </p:cSld>
@@ -524,9 +528,9 @@
           <a:bodyPr/>
           <a:lstStyle/>
           <a:p>
-            <a:fld id="{E0BE65D6-FC4B-4387-9677-FDDBE5B571BA}" type="slidenum">
+            <a:fld id="{1CE3E641-4F17-435E-BCD6-616AEBF8C0F0}" type="slidenum">
               <a:rPr lang="ko-KR" altLang="en-US" smtClean="0"/>
-              <a:t>2</a:t>
+              <a:t>1</a:t>
             </a:fld>
             <a:endParaRPr lang="ko-KR" altLang="en-US"/>
           </a:p>
@@ -535,7 +539,7 @@
     </p:spTree>
     <p:extLst>
       <p:ext uri="{BB962C8B-B14F-4D97-AF65-F5344CB8AC3E}">
-        <p14:creationId xmlns:p14="http://schemas.microsoft.com/office/powerpoint/2010/main" val="4051137418"/>
+        <p14:creationId xmlns:p14="http://schemas.microsoft.com/office/powerpoint/2010/main" val="3680277686"/>
       </p:ext>
     </p:extLst>
   </p:cSld>
@@ -550,7 +554,13 @@
   <p:cSld>
     <p:spTree>
       <p:nvGrpSpPr>
-        <p:cNvPr id="1" name=""/>
+        <p:cNvPr id="1" name="">
+          <a:extLst>
+            <a:ext uri="{FF2B5EF4-FFF2-40B4-BE49-F238E27FC236}">
+              <a16:creationId xmlns:a16="http://schemas.microsoft.com/office/drawing/2014/main" id="{BDFD7EE7-31C5-978E-9C2D-8DCF0B71C26A}"/>
+            </a:ext>
+          </a:extLst>
+        </p:cNvPr>
         <p:cNvGrpSpPr/>
         <p:nvPr/>
       </p:nvGrpSpPr>
@@ -564,7 +574,13 @@
       </p:grpSpPr>
       <p:sp>
         <p:nvSpPr>
-          <p:cNvPr id="2" name="슬라이드 이미지 개체 틀 1"/>
+          <p:cNvPr id="2" name="슬라이드 이미지 개체 틀 1">
+            <a:extLst>
+              <a:ext uri="{FF2B5EF4-FFF2-40B4-BE49-F238E27FC236}">
+                <a16:creationId xmlns:a16="http://schemas.microsoft.com/office/drawing/2014/main" id="{F1EC9888-47B9-7429-C591-8AFCC17B3D69}"/>
+              </a:ext>
+            </a:extLst>
+          </p:cNvPr>
           <p:cNvSpPr>
             <a:spLocks noGrp="1" noRot="1" noChangeAspect="1"/>
           </p:cNvSpPr>
@@ -576,7 +592,13 @@
       </p:sp>
       <p:sp>
         <p:nvSpPr>
-          <p:cNvPr id="3" name="슬라이드 노트 개체 틀 2"/>
+          <p:cNvPr id="3" name="슬라이드 노트 개체 틀 2">
+            <a:extLst>
+              <a:ext uri="{FF2B5EF4-FFF2-40B4-BE49-F238E27FC236}">
+                <a16:creationId xmlns:a16="http://schemas.microsoft.com/office/drawing/2014/main" id="{29307253-AFF6-FDB3-69DF-668DF99A4987}"/>
+              </a:ext>
+            </a:extLst>
+          </p:cNvPr>
           <p:cNvSpPr>
             <a:spLocks noGrp="1"/>
           </p:cNvSpPr>
@@ -589,13 +611,27 @@
           <a:bodyPr/>
           <a:lstStyle/>
           <a:p>
-            <a:endParaRPr lang="ko-KR" altLang="en-US"/>
-          </a:p>
-        </p:txBody>
-      </p:sp>
-      <p:sp>
-        <p:nvSpPr>
-          <p:cNvPr id="4" name="슬라이드 번호 개체 틀 3"/>
+            <a:endParaRPr lang="en-US" altLang="ko-KR" sz="1800">
+              <a:solidFill>
+                <a:srgbClr val="008000"/>
+              </a:solidFill>
+              <a:highlight>
+                <a:srgbClr val="FFFFFF"/>
+              </a:highlight>
+              <a:latin typeface="Cascadia Mono" panose="020B0609020000020004" pitchFamily="49" charset="0"/>
+            </a:endParaRPr>
+          </a:p>
+        </p:txBody>
+      </p:sp>
+      <p:sp>
+        <p:nvSpPr>
+          <p:cNvPr id="4" name="슬라이드 번호 개체 틀 3">
+            <a:extLst>
+              <a:ext uri="{FF2B5EF4-FFF2-40B4-BE49-F238E27FC236}">
+                <a16:creationId xmlns:a16="http://schemas.microsoft.com/office/drawing/2014/main" id="{8BD1B98B-0503-5DD4-26DE-E448B68DA530}"/>
+              </a:ext>
+            </a:extLst>
+          </p:cNvPr>
           <p:cNvSpPr>
             <a:spLocks noGrp="1"/>
           </p:cNvSpPr>
@@ -608,9 +644,9 @@
           <a:bodyPr/>
           <a:lstStyle/>
           <a:p>
-            <a:fld id="{E0BE65D6-FC4B-4387-9677-FDDBE5B571BA}" type="slidenum">
+            <a:fld id="{1CE3E641-4F17-435E-BCD6-616AEBF8C0F0}" type="slidenum">
               <a:rPr lang="ko-KR" altLang="en-US" smtClean="0"/>
-              <a:t>3</a:t>
+              <a:t>2</a:t>
             </a:fld>
             <a:endParaRPr lang="ko-KR" altLang="en-US"/>
           </a:p>
@@ -619,7 +655,7 @@
     </p:spTree>
     <p:extLst>
       <p:ext uri="{BB962C8B-B14F-4D97-AF65-F5344CB8AC3E}">
-        <p14:creationId xmlns:p14="http://schemas.microsoft.com/office/powerpoint/2010/main" val="2315371373"/>
+        <p14:creationId xmlns:p14="http://schemas.microsoft.com/office/powerpoint/2010/main" val="666674096"/>
       </p:ext>
     </p:extLst>
   </p:cSld>
@@ -651,7 +687,7 @@
           <p:cNvPr id="2" name="제목 1">
             <a:extLst>
               <a:ext uri="{FF2B5EF4-FFF2-40B4-BE49-F238E27FC236}">
-                <a16:creationId xmlns:a16="http://schemas.microsoft.com/office/drawing/2014/main" id="{AF67C52A-6ACB-F932-5FF8-ABA9EB31C2CA}"/>
+                <a16:creationId xmlns:a16="http://schemas.microsoft.com/office/drawing/2014/main" id="{6EAE3721-A24B-41A8-4601-659AEB32F201}"/>
               </a:ext>
             </a:extLst>
           </p:cNvPr>
@@ -688,7 +724,7 @@
           <p:cNvPr id="3" name="부제목 2">
             <a:extLst>
               <a:ext uri="{FF2B5EF4-FFF2-40B4-BE49-F238E27FC236}">
-                <a16:creationId xmlns:a16="http://schemas.microsoft.com/office/drawing/2014/main" id="{EE1631F9-3683-BE73-9291-831099A55086}"/>
+                <a16:creationId xmlns:a16="http://schemas.microsoft.com/office/drawing/2014/main" id="{F00D3DD0-5804-29DE-8996-7AA30AEEA3DD}"/>
               </a:ext>
             </a:extLst>
           </p:cNvPr>
@@ -758,7 +794,7 @@
           <p:cNvPr id="4" name="날짜 개체 틀 3">
             <a:extLst>
               <a:ext uri="{FF2B5EF4-FFF2-40B4-BE49-F238E27FC236}">
-                <a16:creationId xmlns:a16="http://schemas.microsoft.com/office/drawing/2014/main" id="{0EC07F43-D444-BD13-484F-CD1693EF6844}"/>
+                <a16:creationId xmlns:a16="http://schemas.microsoft.com/office/drawing/2014/main" id="{7982B0E1-51F2-EE74-A9A6-F7862D6B6705}"/>
               </a:ext>
             </a:extLst>
           </p:cNvPr>
@@ -774,9 +810,9 @@
           <a:bodyPr/>
           <a:lstStyle/>
           <a:p>
-            <a:fld id="{49DDEBD7-486B-43A9-948C-BB74824A90CF}" type="datetimeFigureOut">
+            <a:fld id="{E5D7FBEA-28E1-46BB-A59C-4B2C97545460}" type="datetimeFigureOut">
               <a:rPr lang="ko-KR" altLang="en-US" smtClean="0"/>
-              <a:t>2025-05-15</a:t>
+              <a:t>2025-05-21</a:t>
             </a:fld>
             <a:endParaRPr lang="ko-KR" altLang="en-US"/>
           </a:p>
@@ -787,7 +823,7 @@
           <p:cNvPr id="5" name="바닥글 개체 틀 4">
             <a:extLst>
               <a:ext uri="{FF2B5EF4-FFF2-40B4-BE49-F238E27FC236}">
-                <a16:creationId xmlns:a16="http://schemas.microsoft.com/office/drawing/2014/main" id="{C22ED1B0-3DDD-FEE0-0C62-6F363748C682}"/>
+                <a16:creationId xmlns:a16="http://schemas.microsoft.com/office/drawing/2014/main" id="{FCA70605-164E-D706-2A9C-FFC493154C6F}"/>
               </a:ext>
             </a:extLst>
           </p:cNvPr>
@@ -812,7 +848,7 @@
           <p:cNvPr id="6" name="슬라이드 번호 개체 틀 5">
             <a:extLst>
               <a:ext uri="{FF2B5EF4-FFF2-40B4-BE49-F238E27FC236}">
-                <a16:creationId xmlns:a16="http://schemas.microsoft.com/office/drawing/2014/main" id="{63883664-7249-4AB1-837C-C8BC9D1C6307}"/>
+                <a16:creationId xmlns:a16="http://schemas.microsoft.com/office/drawing/2014/main" id="{34614913-F5BE-F858-AC8A-AD77F88621C2}"/>
               </a:ext>
             </a:extLst>
           </p:cNvPr>
@@ -828,7 +864,7 @@
           <a:bodyPr/>
           <a:lstStyle/>
           <a:p>
-            <a:fld id="{EE324605-CD83-4736-B4E3-14B7EC7E5F9E}" type="slidenum">
+            <a:fld id="{64C94B83-923C-44D9-A936-DC0156CB546B}" type="slidenum">
               <a:rPr lang="ko-KR" altLang="en-US" smtClean="0"/>
               <a:t>‹#›</a:t>
             </a:fld>
@@ -839,7 +875,7 @@
     </p:spTree>
     <p:extLst>
       <p:ext uri="{BB962C8B-B14F-4D97-AF65-F5344CB8AC3E}">
-        <p14:creationId xmlns:p14="http://schemas.microsoft.com/office/powerpoint/2010/main" val="1979201835"/>
+        <p14:creationId xmlns:p14="http://schemas.microsoft.com/office/powerpoint/2010/main" val="3137597550"/>
       </p:ext>
     </p:extLst>
   </p:cSld>
@@ -871,7 +907,7 @@
           <p:cNvPr id="2" name="제목 1">
             <a:extLst>
               <a:ext uri="{FF2B5EF4-FFF2-40B4-BE49-F238E27FC236}">
-                <a16:creationId xmlns:a16="http://schemas.microsoft.com/office/drawing/2014/main" id="{0F0C694F-2619-4544-52D5-8AE7BBBA0CAC}"/>
+                <a16:creationId xmlns:a16="http://schemas.microsoft.com/office/drawing/2014/main" id="{2B895256-93AB-2C92-8EF5-D1118D2E2E6E}"/>
               </a:ext>
             </a:extLst>
           </p:cNvPr>
@@ -899,7 +935,7 @@
           <p:cNvPr id="3" name="세로 텍스트 개체 틀 2">
             <a:extLst>
               <a:ext uri="{FF2B5EF4-FFF2-40B4-BE49-F238E27FC236}">
-                <a16:creationId xmlns:a16="http://schemas.microsoft.com/office/drawing/2014/main" id="{16B21DED-9A0A-2C93-9176-12DD29F3752D}"/>
+                <a16:creationId xmlns:a16="http://schemas.microsoft.com/office/drawing/2014/main" id="{39FDEE2B-94F8-63D4-34D9-FF3F2F657C43}"/>
               </a:ext>
             </a:extLst>
           </p:cNvPr>
@@ -956,7 +992,7 @@
           <p:cNvPr id="4" name="날짜 개체 틀 3">
             <a:extLst>
               <a:ext uri="{FF2B5EF4-FFF2-40B4-BE49-F238E27FC236}">
-                <a16:creationId xmlns:a16="http://schemas.microsoft.com/office/drawing/2014/main" id="{9901DFD4-21E3-0DF6-50B6-ED6044538D6C}"/>
+                <a16:creationId xmlns:a16="http://schemas.microsoft.com/office/drawing/2014/main" id="{EDEBE101-4446-DDBE-2BCB-2CFC09284DCC}"/>
               </a:ext>
             </a:extLst>
           </p:cNvPr>
@@ -972,9 +1008,9 @@
           <a:bodyPr/>
           <a:lstStyle/>
           <a:p>
-            <a:fld id="{49DDEBD7-486B-43A9-948C-BB74824A90CF}" type="datetimeFigureOut">
+            <a:fld id="{E5D7FBEA-28E1-46BB-A59C-4B2C97545460}" type="datetimeFigureOut">
               <a:rPr lang="ko-KR" altLang="en-US" smtClean="0"/>
-              <a:t>2025-05-15</a:t>
+              <a:t>2025-05-21</a:t>
             </a:fld>
             <a:endParaRPr lang="ko-KR" altLang="en-US"/>
           </a:p>
@@ -985,7 +1021,7 @@
           <p:cNvPr id="5" name="바닥글 개체 틀 4">
             <a:extLst>
               <a:ext uri="{FF2B5EF4-FFF2-40B4-BE49-F238E27FC236}">
-                <a16:creationId xmlns:a16="http://schemas.microsoft.com/office/drawing/2014/main" id="{E7BFE60E-E4A8-37E6-0B79-25EBEDF2904A}"/>
+                <a16:creationId xmlns:a16="http://schemas.microsoft.com/office/drawing/2014/main" id="{454C07E4-4120-9F40-83B7-FFDCA963A065}"/>
               </a:ext>
             </a:extLst>
           </p:cNvPr>
@@ -1010,7 +1046,7 @@
           <p:cNvPr id="6" name="슬라이드 번호 개체 틀 5">
             <a:extLst>
               <a:ext uri="{FF2B5EF4-FFF2-40B4-BE49-F238E27FC236}">
-                <a16:creationId xmlns:a16="http://schemas.microsoft.com/office/drawing/2014/main" id="{C00DF747-D05A-55C5-0260-C7D5996C87F5}"/>
+                <a16:creationId xmlns:a16="http://schemas.microsoft.com/office/drawing/2014/main" id="{C2CA4960-6D8E-2C5C-9044-0AE7F220DA9C}"/>
               </a:ext>
             </a:extLst>
           </p:cNvPr>
@@ -1026,7 +1062,7 @@
           <a:bodyPr/>
           <a:lstStyle/>
           <a:p>
-            <a:fld id="{EE324605-CD83-4736-B4E3-14B7EC7E5F9E}" type="slidenum">
+            <a:fld id="{64C94B83-923C-44D9-A936-DC0156CB546B}" type="slidenum">
               <a:rPr lang="ko-KR" altLang="en-US" smtClean="0"/>
               <a:t>‹#›</a:t>
             </a:fld>
@@ -1037,7 +1073,7 @@
     </p:spTree>
     <p:extLst>
       <p:ext uri="{BB962C8B-B14F-4D97-AF65-F5344CB8AC3E}">
-        <p14:creationId xmlns:p14="http://schemas.microsoft.com/office/powerpoint/2010/main" val="960678414"/>
+        <p14:creationId xmlns:p14="http://schemas.microsoft.com/office/powerpoint/2010/main" val="3463427775"/>
       </p:ext>
     </p:extLst>
   </p:cSld>
@@ -1069,7 +1105,7 @@
           <p:cNvPr id="2" name="세로 제목 1">
             <a:extLst>
               <a:ext uri="{FF2B5EF4-FFF2-40B4-BE49-F238E27FC236}">
-                <a16:creationId xmlns:a16="http://schemas.microsoft.com/office/drawing/2014/main" id="{AF096A1B-AB57-02DD-DAB6-AF763F57B637}"/>
+                <a16:creationId xmlns:a16="http://schemas.microsoft.com/office/drawing/2014/main" id="{BF33BFAC-9AF5-FC29-E47F-AF681DD25116}"/>
               </a:ext>
             </a:extLst>
           </p:cNvPr>
@@ -1102,7 +1138,7 @@
           <p:cNvPr id="3" name="세로 텍스트 개체 틀 2">
             <a:extLst>
               <a:ext uri="{FF2B5EF4-FFF2-40B4-BE49-F238E27FC236}">
-                <a16:creationId xmlns:a16="http://schemas.microsoft.com/office/drawing/2014/main" id="{3A60E090-A68D-8CE2-8608-2FCF81B42B2D}"/>
+                <a16:creationId xmlns:a16="http://schemas.microsoft.com/office/drawing/2014/main" id="{6360D6FE-985E-4B8A-3DFA-C51B0BC0946B}"/>
               </a:ext>
             </a:extLst>
           </p:cNvPr>
@@ -1164,7 +1200,7 @@
           <p:cNvPr id="4" name="날짜 개체 틀 3">
             <a:extLst>
               <a:ext uri="{FF2B5EF4-FFF2-40B4-BE49-F238E27FC236}">
-                <a16:creationId xmlns:a16="http://schemas.microsoft.com/office/drawing/2014/main" id="{6EB93C1D-07E6-936E-E1BD-40C61EDA8A33}"/>
+                <a16:creationId xmlns:a16="http://schemas.microsoft.com/office/drawing/2014/main" id="{AB6FD659-1E5C-E7E9-CCA3-DFB2C4DF411C}"/>
               </a:ext>
             </a:extLst>
           </p:cNvPr>
@@ -1180,9 +1216,9 @@
           <a:bodyPr/>
           <a:lstStyle/>
           <a:p>
-            <a:fld id="{49DDEBD7-486B-43A9-948C-BB74824A90CF}" type="datetimeFigureOut">
+            <a:fld id="{E5D7FBEA-28E1-46BB-A59C-4B2C97545460}" type="datetimeFigureOut">
               <a:rPr lang="ko-KR" altLang="en-US" smtClean="0"/>
-              <a:t>2025-05-15</a:t>
+              <a:t>2025-05-21</a:t>
             </a:fld>
             <a:endParaRPr lang="ko-KR" altLang="en-US"/>
           </a:p>
@@ -1193,7 +1229,7 @@
           <p:cNvPr id="5" name="바닥글 개체 틀 4">
             <a:extLst>
               <a:ext uri="{FF2B5EF4-FFF2-40B4-BE49-F238E27FC236}">
-                <a16:creationId xmlns:a16="http://schemas.microsoft.com/office/drawing/2014/main" id="{027FE838-9B00-F890-358C-D8BCFE8C81AC}"/>
+                <a16:creationId xmlns:a16="http://schemas.microsoft.com/office/drawing/2014/main" id="{D46420F1-EAFE-BC0A-EDD2-B6A3AC8142AD}"/>
               </a:ext>
             </a:extLst>
           </p:cNvPr>
@@ -1218,7 +1254,7 @@
           <p:cNvPr id="6" name="슬라이드 번호 개체 틀 5">
             <a:extLst>
               <a:ext uri="{FF2B5EF4-FFF2-40B4-BE49-F238E27FC236}">
-                <a16:creationId xmlns:a16="http://schemas.microsoft.com/office/drawing/2014/main" id="{39A548B3-FE5B-A38E-817D-17F26743393D}"/>
+                <a16:creationId xmlns:a16="http://schemas.microsoft.com/office/drawing/2014/main" id="{26A0DB14-CA9F-EB50-016A-6A898F34FAD8}"/>
               </a:ext>
             </a:extLst>
           </p:cNvPr>
@@ -1234,7 +1270,7 @@
           <a:bodyPr/>
           <a:lstStyle/>
           <a:p>
-            <a:fld id="{EE324605-CD83-4736-B4E3-14B7EC7E5F9E}" type="slidenum">
+            <a:fld id="{64C94B83-923C-44D9-A936-DC0156CB546B}" type="slidenum">
               <a:rPr lang="ko-KR" altLang="en-US" smtClean="0"/>
               <a:t>‹#›</a:t>
             </a:fld>
@@ -1245,7 +1281,7 @@
     </p:spTree>
     <p:extLst>
       <p:ext uri="{BB962C8B-B14F-4D97-AF65-F5344CB8AC3E}">
-        <p14:creationId xmlns:p14="http://schemas.microsoft.com/office/powerpoint/2010/main" val="16776940"/>
+        <p14:creationId xmlns:p14="http://schemas.microsoft.com/office/powerpoint/2010/main" val="2926913304"/>
       </p:ext>
     </p:extLst>
   </p:cSld>
@@ -1277,7 +1313,7 @@
           <p:cNvPr id="2" name="제목 1">
             <a:extLst>
               <a:ext uri="{FF2B5EF4-FFF2-40B4-BE49-F238E27FC236}">
-                <a16:creationId xmlns:a16="http://schemas.microsoft.com/office/drawing/2014/main" id="{EEBBC716-04F3-00CD-A62E-36CE2F769C22}"/>
+                <a16:creationId xmlns:a16="http://schemas.microsoft.com/office/drawing/2014/main" id="{76CB62CE-CA63-D2FD-8D88-B6AC7B70F8DA}"/>
               </a:ext>
             </a:extLst>
           </p:cNvPr>
@@ -1305,7 +1341,7 @@
           <p:cNvPr id="3" name="내용 개체 틀 2">
             <a:extLst>
               <a:ext uri="{FF2B5EF4-FFF2-40B4-BE49-F238E27FC236}">
-                <a16:creationId xmlns:a16="http://schemas.microsoft.com/office/drawing/2014/main" id="{7E2CC77E-7670-D07D-A309-A709EF7B7C6A}"/>
+                <a16:creationId xmlns:a16="http://schemas.microsoft.com/office/drawing/2014/main" id="{68C06FD1-F9AB-6BA8-6AF3-AF362CA4D461}"/>
               </a:ext>
             </a:extLst>
           </p:cNvPr>
@@ -1362,7 +1398,7 @@
           <p:cNvPr id="4" name="날짜 개체 틀 3">
             <a:extLst>
               <a:ext uri="{FF2B5EF4-FFF2-40B4-BE49-F238E27FC236}">
-                <a16:creationId xmlns:a16="http://schemas.microsoft.com/office/drawing/2014/main" id="{C9356566-440A-D3F8-395A-0AD33D36DE1D}"/>
+                <a16:creationId xmlns:a16="http://schemas.microsoft.com/office/drawing/2014/main" id="{88F5B1E5-A040-17A4-CBC0-D9F56BD2330A}"/>
               </a:ext>
             </a:extLst>
           </p:cNvPr>
@@ -1378,9 +1414,9 @@
           <a:bodyPr/>
           <a:lstStyle/>
           <a:p>
-            <a:fld id="{49DDEBD7-486B-43A9-948C-BB74824A90CF}" type="datetimeFigureOut">
+            <a:fld id="{E5D7FBEA-28E1-46BB-A59C-4B2C97545460}" type="datetimeFigureOut">
               <a:rPr lang="ko-KR" altLang="en-US" smtClean="0"/>
-              <a:t>2025-05-15</a:t>
+              <a:t>2025-05-21</a:t>
             </a:fld>
             <a:endParaRPr lang="ko-KR" altLang="en-US"/>
           </a:p>
@@ -1391,7 +1427,7 @@
           <p:cNvPr id="5" name="바닥글 개체 틀 4">
             <a:extLst>
               <a:ext uri="{FF2B5EF4-FFF2-40B4-BE49-F238E27FC236}">
-                <a16:creationId xmlns:a16="http://schemas.microsoft.com/office/drawing/2014/main" id="{73AB9C61-8D10-4B5F-871D-BE35854075F7}"/>
+                <a16:creationId xmlns:a16="http://schemas.microsoft.com/office/drawing/2014/main" id="{6E345849-EC7A-230F-6E57-D61ABE4E1CB3}"/>
               </a:ext>
             </a:extLst>
           </p:cNvPr>
@@ -1416,7 +1452,7 @@
           <p:cNvPr id="6" name="슬라이드 번호 개체 틀 5">
             <a:extLst>
               <a:ext uri="{FF2B5EF4-FFF2-40B4-BE49-F238E27FC236}">
-                <a16:creationId xmlns:a16="http://schemas.microsoft.com/office/drawing/2014/main" id="{75D4C602-A9BF-C871-AE6E-08D1C210DB52}"/>
+                <a16:creationId xmlns:a16="http://schemas.microsoft.com/office/drawing/2014/main" id="{78779722-CCD2-EAC0-B4CC-14F82FB73975}"/>
               </a:ext>
             </a:extLst>
           </p:cNvPr>
@@ -1432,7 +1468,7 @@
           <a:bodyPr/>
           <a:lstStyle/>
           <a:p>
-            <a:fld id="{EE324605-CD83-4736-B4E3-14B7EC7E5F9E}" type="slidenum">
+            <a:fld id="{64C94B83-923C-44D9-A936-DC0156CB546B}" type="slidenum">
               <a:rPr lang="ko-KR" altLang="en-US" smtClean="0"/>
               <a:t>‹#›</a:t>
             </a:fld>
@@ -1443,7 +1479,7 @@
     </p:spTree>
     <p:extLst>
       <p:ext uri="{BB962C8B-B14F-4D97-AF65-F5344CB8AC3E}">
-        <p14:creationId xmlns:p14="http://schemas.microsoft.com/office/powerpoint/2010/main" val="418802051"/>
+        <p14:creationId xmlns:p14="http://schemas.microsoft.com/office/powerpoint/2010/main" val="3713778782"/>
       </p:ext>
     </p:extLst>
   </p:cSld>
@@ -1475,7 +1511,7 @@
           <p:cNvPr id="2" name="제목 1">
             <a:extLst>
               <a:ext uri="{FF2B5EF4-FFF2-40B4-BE49-F238E27FC236}">
-                <a16:creationId xmlns:a16="http://schemas.microsoft.com/office/drawing/2014/main" id="{0AAA9535-83CF-1132-298D-49BCA5FDC5FD}"/>
+                <a16:creationId xmlns:a16="http://schemas.microsoft.com/office/drawing/2014/main" id="{F26CF9F8-BBEC-8893-3F55-E6C3A7DF34D9}"/>
               </a:ext>
             </a:extLst>
           </p:cNvPr>
@@ -1512,7 +1548,7 @@
           <p:cNvPr id="3" name="텍스트 개체 틀 2">
             <a:extLst>
               <a:ext uri="{FF2B5EF4-FFF2-40B4-BE49-F238E27FC236}">
-                <a16:creationId xmlns:a16="http://schemas.microsoft.com/office/drawing/2014/main" id="{5537B1DD-E725-B9D9-0570-561DDE21DE98}"/>
+                <a16:creationId xmlns:a16="http://schemas.microsoft.com/office/drawing/2014/main" id="{46816D03-D513-AAE2-7F75-D05381A9CC74}"/>
               </a:ext>
             </a:extLst>
           </p:cNvPr>
@@ -1637,7 +1673,7 @@
           <p:cNvPr id="4" name="날짜 개체 틀 3">
             <a:extLst>
               <a:ext uri="{FF2B5EF4-FFF2-40B4-BE49-F238E27FC236}">
-                <a16:creationId xmlns:a16="http://schemas.microsoft.com/office/drawing/2014/main" id="{6CF230EE-B2AA-A2C9-940F-9C0F06525A67}"/>
+                <a16:creationId xmlns:a16="http://schemas.microsoft.com/office/drawing/2014/main" id="{6CD249AB-4024-E3C8-517A-8223EE3F2F3E}"/>
               </a:ext>
             </a:extLst>
           </p:cNvPr>
@@ -1653,9 +1689,9 @@
           <a:bodyPr/>
           <a:lstStyle/>
           <a:p>
-            <a:fld id="{49DDEBD7-486B-43A9-948C-BB74824A90CF}" type="datetimeFigureOut">
+            <a:fld id="{E5D7FBEA-28E1-46BB-A59C-4B2C97545460}" type="datetimeFigureOut">
               <a:rPr lang="ko-KR" altLang="en-US" smtClean="0"/>
-              <a:t>2025-05-15</a:t>
+              <a:t>2025-05-21</a:t>
             </a:fld>
             <a:endParaRPr lang="ko-KR" altLang="en-US"/>
           </a:p>
@@ -1666,7 +1702,7 @@
           <p:cNvPr id="5" name="바닥글 개체 틀 4">
             <a:extLst>
               <a:ext uri="{FF2B5EF4-FFF2-40B4-BE49-F238E27FC236}">
-                <a16:creationId xmlns:a16="http://schemas.microsoft.com/office/drawing/2014/main" id="{E7E93A13-A5DB-DDE0-B95F-B571B2F3A30E}"/>
+                <a16:creationId xmlns:a16="http://schemas.microsoft.com/office/drawing/2014/main" id="{E0142A53-B143-643D-E9C9-BFEE12D9EF8E}"/>
               </a:ext>
             </a:extLst>
           </p:cNvPr>
@@ -1691,7 +1727,7 @@
           <p:cNvPr id="6" name="슬라이드 번호 개체 틀 5">
             <a:extLst>
               <a:ext uri="{FF2B5EF4-FFF2-40B4-BE49-F238E27FC236}">
-                <a16:creationId xmlns:a16="http://schemas.microsoft.com/office/drawing/2014/main" id="{D8B09F2B-7F9C-4755-085D-FD51F267E71F}"/>
+                <a16:creationId xmlns:a16="http://schemas.microsoft.com/office/drawing/2014/main" id="{E552855E-2709-8515-C403-139603AD200D}"/>
               </a:ext>
             </a:extLst>
           </p:cNvPr>
@@ -1707,7 +1743,7 @@
           <a:bodyPr/>
           <a:lstStyle/>
           <a:p>
-            <a:fld id="{EE324605-CD83-4736-B4E3-14B7EC7E5F9E}" type="slidenum">
+            <a:fld id="{64C94B83-923C-44D9-A936-DC0156CB546B}" type="slidenum">
               <a:rPr lang="ko-KR" altLang="en-US" smtClean="0"/>
               <a:t>‹#›</a:t>
             </a:fld>
@@ -1718,7 +1754,7 @@
     </p:spTree>
     <p:extLst>
       <p:ext uri="{BB962C8B-B14F-4D97-AF65-F5344CB8AC3E}">
-        <p14:creationId xmlns:p14="http://schemas.microsoft.com/office/powerpoint/2010/main" val="2401007276"/>
+        <p14:creationId xmlns:p14="http://schemas.microsoft.com/office/powerpoint/2010/main" val="3979081628"/>
       </p:ext>
     </p:extLst>
   </p:cSld>
@@ -1750,7 +1786,7 @@
           <p:cNvPr id="2" name="제목 1">
             <a:extLst>
               <a:ext uri="{FF2B5EF4-FFF2-40B4-BE49-F238E27FC236}">
-                <a16:creationId xmlns:a16="http://schemas.microsoft.com/office/drawing/2014/main" id="{40F63CE9-7C6D-CB45-2F23-C84724BC3368}"/>
+                <a16:creationId xmlns:a16="http://schemas.microsoft.com/office/drawing/2014/main" id="{75E05F70-9667-06D6-17CC-90FCDC8C3897}"/>
               </a:ext>
             </a:extLst>
           </p:cNvPr>
@@ -1778,7 +1814,7 @@
           <p:cNvPr id="3" name="내용 개체 틀 2">
             <a:extLst>
               <a:ext uri="{FF2B5EF4-FFF2-40B4-BE49-F238E27FC236}">
-                <a16:creationId xmlns:a16="http://schemas.microsoft.com/office/drawing/2014/main" id="{62D130C6-C41A-30E9-4D5E-5AB2E91679F8}"/>
+                <a16:creationId xmlns:a16="http://schemas.microsoft.com/office/drawing/2014/main" id="{8F05636C-9479-1E52-F2A8-AD8528594BC7}"/>
               </a:ext>
             </a:extLst>
           </p:cNvPr>
@@ -1840,7 +1876,7 @@
           <p:cNvPr id="4" name="내용 개체 틀 3">
             <a:extLst>
               <a:ext uri="{FF2B5EF4-FFF2-40B4-BE49-F238E27FC236}">
-                <a16:creationId xmlns:a16="http://schemas.microsoft.com/office/drawing/2014/main" id="{B1785F68-2D87-C2B4-97A5-5A9F73963EAC}"/>
+                <a16:creationId xmlns:a16="http://schemas.microsoft.com/office/drawing/2014/main" id="{97F1292E-4628-18AC-40FF-730CA7F2FA66}"/>
               </a:ext>
             </a:extLst>
           </p:cNvPr>
@@ -1902,7 +1938,7 @@
           <p:cNvPr id="5" name="날짜 개체 틀 4">
             <a:extLst>
               <a:ext uri="{FF2B5EF4-FFF2-40B4-BE49-F238E27FC236}">
-                <a16:creationId xmlns:a16="http://schemas.microsoft.com/office/drawing/2014/main" id="{3E9437C2-0B55-1250-C1E8-9BA4AB9026AD}"/>
+                <a16:creationId xmlns:a16="http://schemas.microsoft.com/office/drawing/2014/main" id="{FCF64DCF-A3EB-A196-A93F-C2A893BF8B2F}"/>
               </a:ext>
             </a:extLst>
           </p:cNvPr>
@@ -1918,9 +1954,9 @@
           <a:bodyPr/>
           <a:lstStyle/>
           <a:p>
-            <a:fld id="{49DDEBD7-486B-43A9-948C-BB74824A90CF}" type="datetimeFigureOut">
+            <a:fld id="{E5D7FBEA-28E1-46BB-A59C-4B2C97545460}" type="datetimeFigureOut">
               <a:rPr lang="ko-KR" altLang="en-US" smtClean="0"/>
-              <a:t>2025-05-15</a:t>
+              <a:t>2025-05-21</a:t>
             </a:fld>
             <a:endParaRPr lang="ko-KR" altLang="en-US"/>
           </a:p>
@@ -1931,7 +1967,7 @@
           <p:cNvPr id="6" name="바닥글 개체 틀 5">
             <a:extLst>
               <a:ext uri="{FF2B5EF4-FFF2-40B4-BE49-F238E27FC236}">
-                <a16:creationId xmlns:a16="http://schemas.microsoft.com/office/drawing/2014/main" id="{D801E919-FC35-6085-91CD-4C85090BB577}"/>
+                <a16:creationId xmlns:a16="http://schemas.microsoft.com/office/drawing/2014/main" id="{516E80BF-6111-06BF-C4B1-E8719C3C7805}"/>
               </a:ext>
             </a:extLst>
           </p:cNvPr>
@@ -1956,7 +1992,7 @@
           <p:cNvPr id="7" name="슬라이드 번호 개체 틀 6">
             <a:extLst>
               <a:ext uri="{FF2B5EF4-FFF2-40B4-BE49-F238E27FC236}">
-                <a16:creationId xmlns:a16="http://schemas.microsoft.com/office/drawing/2014/main" id="{F3560EA3-D1A0-8B7F-D5A6-1828621F200E}"/>
+                <a16:creationId xmlns:a16="http://schemas.microsoft.com/office/drawing/2014/main" id="{66610693-65CB-6F81-556E-136A794C5913}"/>
               </a:ext>
             </a:extLst>
           </p:cNvPr>
@@ -1972,7 +2008,7 @@
           <a:bodyPr/>
           <a:lstStyle/>
           <a:p>
-            <a:fld id="{EE324605-CD83-4736-B4E3-14B7EC7E5F9E}" type="slidenum">
+            <a:fld id="{64C94B83-923C-44D9-A936-DC0156CB546B}" type="slidenum">
               <a:rPr lang="ko-KR" altLang="en-US" smtClean="0"/>
               <a:t>‹#›</a:t>
             </a:fld>
@@ -1983,7 +2019,7 @@
     </p:spTree>
     <p:extLst>
       <p:ext uri="{BB962C8B-B14F-4D97-AF65-F5344CB8AC3E}">
-        <p14:creationId xmlns:p14="http://schemas.microsoft.com/office/powerpoint/2010/main" val="737402544"/>
+        <p14:creationId xmlns:p14="http://schemas.microsoft.com/office/powerpoint/2010/main" val="3728269551"/>
       </p:ext>
     </p:extLst>
   </p:cSld>
@@ -2015,7 +2051,7 @@
           <p:cNvPr id="2" name="제목 1">
             <a:extLst>
               <a:ext uri="{FF2B5EF4-FFF2-40B4-BE49-F238E27FC236}">
-                <a16:creationId xmlns:a16="http://schemas.microsoft.com/office/drawing/2014/main" id="{76C5180D-196D-FC75-49A8-9D8614168B66}"/>
+                <a16:creationId xmlns:a16="http://schemas.microsoft.com/office/drawing/2014/main" id="{C2E608E2-CA5B-E286-6D27-F31BE5EE2289}"/>
               </a:ext>
             </a:extLst>
           </p:cNvPr>
@@ -2048,7 +2084,7 @@
           <p:cNvPr id="3" name="텍스트 개체 틀 2">
             <a:extLst>
               <a:ext uri="{FF2B5EF4-FFF2-40B4-BE49-F238E27FC236}">
-                <a16:creationId xmlns:a16="http://schemas.microsoft.com/office/drawing/2014/main" id="{8B4816E7-7F21-9018-8C86-0F775F1109CA}"/>
+                <a16:creationId xmlns:a16="http://schemas.microsoft.com/office/drawing/2014/main" id="{8C0CD917-978C-F383-BCF2-2A22A7B964E6}"/>
               </a:ext>
             </a:extLst>
           </p:cNvPr>
@@ -2119,7 +2155,7 @@
           <p:cNvPr id="4" name="내용 개체 틀 3">
             <a:extLst>
               <a:ext uri="{FF2B5EF4-FFF2-40B4-BE49-F238E27FC236}">
-                <a16:creationId xmlns:a16="http://schemas.microsoft.com/office/drawing/2014/main" id="{4D33CF25-0634-629A-4317-47D5F594C93F}"/>
+                <a16:creationId xmlns:a16="http://schemas.microsoft.com/office/drawing/2014/main" id="{5D9CD61F-72A1-180E-E157-D29763CBC5AD}"/>
               </a:ext>
             </a:extLst>
           </p:cNvPr>
@@ -2181,7 +2217,7 @@
           <p:cNvPr id="5" name="텍스트 개체 틀 4">
             <a:extLst>
               <a:ext uri="{FF2B5EF4-FFF2-40B4-BE49-F238E27FC236}">
-                <a16:creationId xmlns:a16="http://schemas.microsoft.com/office/drawing/2014/main" id="{C7389035-B320-7243-428C-15BF0F15C567}"/>
+                <a16:creationId xmlns:a16="http://schemas.microsoft.com/office/drawing/2014/main" id="{F20CF763-DBEE-82B9-B571-FF56FAF868FD}"/>
               </a:ext>
             </a:extLst>
           </p:cNvPr>
@@ -2252,7 +2288,7 @@
           <p:cNvPr id="6" name="내용 개체 틀 5">
             <a:extLst>
               <a:ext uri="{FF2B5EF4-FFF2-40B4-BE49-F238E27FC236}">
-                <a16:creationId xmlns:a16="http://schemas.microsoft.com/office/drawing/2014/main" id="{4A074EA6-4FDF-4D8D-4E42-2699C17430FA}"/>
+                <a16:creationId xmlns:a16="http://schemas.microsoft.com/office/drawing/2014/main" id="{728809DD-4903-446D-4DC5-2D7237587AAD}"/>
               </a:ext>
             </a:extLst>
           </p:cNvPr>
@@ -2314,7 +2350,7 @@
           <p:cNvPr id="7" name="날짜 개체 틀 6">
             <a:extLst>
               <a:ext uri="{FF2B5EF4-FFF2-40B4-BE49-F238E27FC236}">
-                <a16:creationId xmlns:a16="http://schemas.microsoft.com/office/drawing/2014/main" id="{CF4FF441-15E3-1D57-32A0-6E047762D2D5}"/>
+                <a16:creationId xmlns:a16="http://schemas.microsoft.com/office/drawing/2014/main" id="{DE24866A-B06F-F128-FBD9-12D5B51674EE}"/>
               </a:ext>
             </a:extLst>
           </p:cNvPr>
@@ -2330,9 +2366,9 @@
           <a:bodyPr/>
           <a:lstStyle/>
           <a:p>
-            <a:fld id="{49DDEBD7-486B-43A9-948C-BB74824A90CF}" type="datetimeFigureOut">
+            <a:fld id="{E5D7FBEA-28E1-46BB-A59C-4B2C97545460}" type="datetimeFigureOut">
               <a:rPr lang="ko-KR" altLang="en-US" smtClean="0"/>
-              <a:t>2025-05-15</a:t>
+              <a:t>2025-05-21</a:t>
             </a:fld>
             <a:endParaRPr lang="ko-KR" altLang="en-US"/>
           </a:p>
@@ -2343,7 +2379,7 @@
           <p:cNvPr id="8" name="바닥글 개체 틀 7">
             <a:extLst>
               <a:ext uri="{FF2B5EF4-FFF2-40B4-BE49-F238E27FC236}">
-                <a16:creationId xmlns:a16="http://schemas.microsoft.com/office/drawing/2014/main" id="{B51A5325-3362-00EC-5B80-86B4DFBDB1CA}"/>
+                <a16:creationId xmlns:a16="http://schemas.microsoft.com/office/drawing/2014/main" id="{EEFE9EB6-89CD-8585-BFB1-3BA86983E59E}"/>
               </a:ext>
             </a:extLst>
           </p:cNvPr>
@@ -2368,7 +2404,7 @@
           <p:cNvPr id="9" name="슬라이드 번호 개체 틀 8">
             <a:extLst>
               <a:ext uri="{FF2B5EF4-FFF2-40B4-BE49-F238E27FC236}">
-                <a16:creationId xmlns:a16="http://schemas.microsoft.com/office/drawing/2014/main" id="{F64D8A48-DF21-3467-7FC1-76A6282FD6BB}"/>
+                <a16:creationId xmlns:a16="http://schemas.microsoft.com/office/drawing/2014/main" id="{6E9B03AB-47F1-3C28-1381-52B3D4E3EBAF}"/>
               </a:ext>
             </a:extLst>
           </p:cNvPr>
@@ -2384,7 +2420,7 @@
           <a:bodyPr/>
           <a:lstStyle/>
           <a:p>
-            <a:fld id="{EE324605-CD83-4736-B4E3-14B7EC7E5F9E}" type="slidenum">
+            <a:fld id="{64C94B83-923C-44D9-A936-DC0156CB546B}" type="slidenum">
               <a:rPr lang="ko-KR" altLang="en-US" smtClean="0"/>
               <a:t>‹#›</a:t>
             </a:fld>
@@ -2395,7 +2431,7 @@
     </p:spTree>
     <p:extLst>
       <p:ext uri="{BB962C8B-B14F-4D97-AF65-F5344CB8AC3E}">
-        <p14:creationId xmlns:p14="http://schemas.microsoft.com/office/powerpoint/2010/main" val="553524403"/>
+        <p14:creationId xmlns:p14="http://schemas.microsoft.com/office/powerpoint/2010/main" val="936600431"/>
       </p:ext>
     </p:extLst>
   </p:cSld>
@@ -2427,7 +2463,7 @@
           <p:cNvPr id="2" name="제목 1">
             <a:extLst>
               <a:ext uri="{FF2B5EF4-FFF2-40B4-BE49-F238E27FC236}">
-                <a16:creationId xmlns:a16="http://schemas.microsoft.com/office/drawing/2014/main" id="{C8BB1EBC-1CF5-2CE3-6F1D-EF63117D5A40}"/>
+                <a16:creationId xmlns:a16="http://schemas.microsoft.com/office/drawing/2014/main" id="{4FB161E7-48B9-534C-B0ED-E91EF394248E}"/>
               </a:ext>
             </a:extLst>
           </p:cNvPr>
@@ -2455,7 +2491,7 @@
           <p:cNvPr id="3" name="날짜 개체 틀 2">
             <a:extLst>
               <a:ext uri="{FF2B5EF4-FFF2-40B4-BE49-F238E27FC236}">
-                <a16:creationId xmlns:a16="http://schemas.microsoft.com/office/drawing/2014/main" id="{C36E3440-9AFA-BEA1-3B5F-CE2C60E4D17C}"/>
+                <a16:creationId xmlns:a16="http://schemas.microsoft.com/office/drawing/2014/main" id="{B1FC7A79-527E-8B53-725D-BA5C7066A14E}"/>
               </a:ext>
             </a:extLst>
           </p:cNvPr>
@@ -2471,9 +2507,9 @@
           <a:bodyPr/>
           <a:lstStyle/>
           <a:p>
-            <a:fld id="{49DDEBD7-486B-43A9-948C-BB74824A90CF}" type="datetimeFigureOut">
+            <a:fld id="{E5D7FBEA-28E1-46BB-A59C-4B2C97545460}" type="datetimeFigureOut">
               <a:rPr lang="ko-KR" altLang="en-US" smtClean="0"/>
-              <a:t>2025-05-15</a:t>
+              <a:t>2025-05-21</a:t>
             </a:fld>
             <a:endParaRPr lang="ko-KR" altLang="en-US"/>
           </a:p>
@@ -2484,7 +2520,7 @@
           <p:cNvPr id="4" name="바닥글 개체 틀 3">
             <a:extLst>
               <a:ext uri="{FF2B5EF4-FFF2-40B4-BE49-F238E27FC236}">
-                <a16:creationId xmlns:a16="http://schemas.microsoft.com/office/drawing/2014/main" id="{350A0135-A607-8176-0A81-711E2348AD0E}"/>
+                <a16:creationId xmlns:a16="http://schemas.microsoft.com/office/drawing/2014/main" id="{49843441-81E1-5DF1-E0B6-28048F3B57CD}"/>
               </a:ext>
             </a:extLst>
           </p:cNvPr>
@@ -2509,7 +2545,7 @@
           <p:cNvPr id="5" name="슬라이드 번호 개체 틀 4">
             <a:extLst>
               <a:ext uri="{FF2B5EF4-FFF2-40B4-BE49-F238E27FC236}">
-                <a16:creationId xmlns:a16="http://schemas.microsoft.com/office/drawing/2014/main" id="{080191CF-EC4E-0BAC-6298-937D54B62F4A}"/>
+                <a16:creationId xmlns:a16="http://schemas.microsoft.com/office/drawing/2014/main" id="{79558130-95CF-C6CD-ED36-EF50540B36AE}"/>
               </a:ext>
             </a:extLst>
           </p:cNvPr>
@@ -2525,7 +2561,7 @@
           <a:bodyPr/>
           <a:lstStyle/>
           <a:p>
-            <a:fld id="{EE324605-CD83-4736-B4E3-14B7EC7E5F9E}" type="slidenum">
+            <a:fld id="{64C94B83-923C-44D9-A936-DC0156CB546B}" type="slidenum">
               <a:rPr lang="ko-KR" altLang="en-US" smtClean="0"/>
               <a:t>‹#›</a:t>
             </a:fld>
@@ -2536,7 +2572,7 @@
     </p:spTree>
     <p:extLst>
       <p:ext uri="{BB962C8B-B14F-4D97-AF65-F5344CB8AC3E}">
-        <p14:creationId xmlns:p14="http://schemas.microsoft.com/office/powerpoint/2010/main" val="475318595"/>
+        <p14:creationId xmlns:p14="http://schemas.microsoft.com/office/powerpoint/2010/main" val="1043829279"/>
       </p:ext>
     </p:extLst>
   </p:cSld>
@@ -2568,7 +2604,7 @@
           <p:cNvPr id="2" name="날짜 개체 틀 1">
             <a:extLst>
               <a:ext uri="{FF2B5EF4-FFF2-40B4-BE49-F238E27FC236}">
-                <a16:creationId xmlns:a16="http://schemas.microsoft.com/office/drawing/2014/main" id="{DB37CDA4-02D9-3C63-DE69-FEC8E3169FE4}"/>
+                <a16:creationId xmlns:a16="http://schemas.microsoft.com/office/drawing/2014/main" id="{923F1E97-9950-BB48-18E9-671A7527C55A}"/>
               </a:ext>
             </a:extLst>
           </p:cNvPr>
@@ -2584,9 +2620,9 @@
           <a:bodyPr/>
           <a:lstStyle/>
           <a:p>
-            <a:fld id="{49DDEBD7-486B-43A9-948C-BB74824A90CF}" type="datetimeFigureOut">
+            <a:fld id="{E5D7FBEA-28E1-46BB-A59C-4B2C97545460}" type="datetimeFigureOut">
               <a:rPr lang="ko-KR" altLang="en-US" smtClean="0"/>
-              <a:t>2025-05-15</a:t>
+              <a:t>2025-05-21</a:t>
             </a:fld>
             <a:endParaRPr lang="ko-KR" altLang="en-US"/>
           </a:p>
@@ -2597,7 +2633,7 @@
           <p:cNvPr id="3" name="바닥글 개체 틀 2">
             <a:extLst>
               <a:ext uri="{FF2B5EF4-FFF2-40B4-BE49-F238E27FC236}">
-                <a16:creationId xmlns:a16="http://schemas.microsoft.com/office/drawing/2014/main" id="{9B283924-50CD-5814-50A0-8D2A66AEDA99}"/>
+                <a16:creationId xmlns:a16="http://schemas.microsoft.com/office/drawing/2014/main" id="{E710D256-6081-571B-D37C-FAAD8BFF1400}"/>
               </a:ext>
             </a:extLst>
           </p:cNvPr>
@@ -2622,7 +2658,7 @@
           <p:cNvPr id="4" name="슬라이드 번호 개체 틀 3">
             <a:extLst>
               <a:ext uri="{FF2B5EF4-FFF2-40B4-BE49-F238E27FC236}">
-                <a16:creationId xmlns:a16="http://schemas.microsoft.com/office/drawing/2014/main" id="{A90FC974-CECC-EADE-A3F0-8AFA9608E25B}"/>
+                <a16:creationId xmlns:a16="http://schemas.microsoft.com/office/drawing/2014/main" id="{E3769148-B31A-7FCD-6F20-287BB265D7F8}"/>
               </a:ext>
             </a:extLst>
           </p:cNvPr>
@@ -2638,7 +2674,7 @@
           <a:bodyPr/>
           <a:lstStyle/>
           <a:p>
-            <a:fld id="{EE324605-CD83-4736-B4E3-14B7EC7E5F9E}" type="slidenum">
+            <a:fld id="{64C94B83-923C-44D9-A936-DC0156CB546B}" type="slidenum">
               <a:rPr lang="ko-KR" altLang="en-US" smtClean="0"/>
               <a:t>‹#›</a:t>
             </a:fld>
@@ -2649,7 +2685,7 @@
     </p:spTree>
     <p:extLst>
       <p:ext uri="{BB962C8B-B14F-4D97-AF65-F5344CB8AC3E}">
-        <p14:creationId xmlns:p14="http://schemas.microsoft.com/office/powerpoint/2010/main" val="1064059922"/>
+        <p14:creationId xmlns:p14="http://schemas.microsoft.com/office/powerpoint/2010/main" val="579562513"/>
       </p:ext>
     </p:extLst>
   </p:cSld>
@@ -2681,7 +2717,7 @@
           <p:cNvPr id="2" name="제목 1">
             <a:extLst>
               <a:ext uri="{FF2B5EF4-FFF2-40B4-BE49-F238E27FC236}">
-                <a16:creationId xmlns:a16="http://schemas.microsoft.com/office/drawing/2014/main" id="{4D4CED01-2B86-48F9-C294-D3E472171212}"/>
+                <a16:creationId xmlns:a16="http://schemas.microsoft.com/office/drawing/2014/main" id="{14FD5DED-AAE5-C161-5C68-3AA8CA461083}"/>
               </a:ext>
             </a:extLst>
           </p:cNvPr>
@@ -2718,7 +2754,7 @@
           <p:cNvPr id="3" name="내용 개체 틀 2">
             <a:extLst>
               <a:ext uri="{FF2B5EF4-FFF2-40B4-BE49-F238E27FC236}">
-                <a16:creationId xmlns:a16="http://schemas.microsoft.com/office/drawing/2014/main" id="{D9130CE5-9EBA-8D12-9360-38DBFDF3EA9F}"/>
+                <a16:creationId xmlns:a16="http://schemas.microsoft.com/office/drawing/2014/main" id="{BDD25DA8-D302-34C2-2589-88F68DFE2231}"/>
               </a:ext>
             </a:extLst>
           </p:cNvPr>
@@ -2808,7 +2844,7 @@
           <p:cNvPr id="4" name="텍스트 개체 틀 3">
             <a:extLst>
               <a:ext uri="{FF2B5EF4-FFF2-40B4-BE49-F238E27FC236}">
-                <a16:creationId xmlns:a16="http://schemas.microsoft.com/office/drawing/2014/main" id="{49ACF1A1-D809-9A35-318C-1D791483A956}"/>
+                <a16:creationId xmlns:a16="http://schemas.microsoft.com/office/drawing/2014/main" id="{E69377BB-333B-FDB9-3D34-E0086F8D96BD}"/>
               </a:ext>
             </a:extLst>
           </p:cNvPr>
@@ -2879,7 +2915,7 @@
           <p:cNvPr id="5" name="날짜 개체 틀 4">
             <a:extLst>
               <a:ext uri="{FF2B5EF4-FFF2-40B4-BE49-F238E27FC236}">
-                <a16:creationId xmlns:a16="http://schemas.microsoft.com/office/drawing/2014/main" id="{7E8C04FD-D669-48B0-E57A-A97621811810}"/>
+                <a16:creationId xmlns:a16="http://schemas.microsoft.com/office/drawing/2014/main" id="{20DC7EBC-F62B-DD79-2517-86D0212D04EF}"/>
               </a:ext>
             </a:extLst>
           </p:cNvPr>
@@ -2895,9 +2931,9 @@
           <a:bodyPr/>
           <a:lstStyle/>
           <a:p>
-            <a:fld id="{49DDEBD7-486B-43A9-948C-BB74824A90CF}" type="datetimeFigureOut">
+            <a:fld id="{E5D7FBEA-28E1-46BB-A59C-4B2C97545460}" type="datetimeFigureOut">
               <a:rPr lang="ko-KR" altLang="en-US" smtClean="0"/>
-              <a:t>2025-05-15</a:t>
+              <a:t>2025-05-21</a:t>
             </a:fld>
             <a:endParaRPr lang="ko-KR" altLang="en-US"/>
           </a:p>
@@ -2908,7 +2944,7 @@
           <p:cNvPr id="6" name="바닥글 개체 틀 5">
             <a:extLst>
               <a:ext uri="{FF2B5EF4-FFF2-40B4-BE49-F238E27FC236}">
-                <a16:creationId xmlns:a16="http://schemas.microsoft.com/office/drawing/2014/main" id="{A75F3DD9-9616-EB58-6C70-2752B2A190ED}"/>
+                <a16:creationId xmlns:a16="http://schemas.microsoft.com/office/drawing/2014/main" id="{CD689C87-58BF-23BA-B9AB-E4C85BABEA0A}"/>
               </a:ext>
             </a:extLst>
           </p:cNvPr>
@@ -2933,7 +2969,7 @@
           <p:cNvPr id="7" name="슬라이드 번호 개체 틀 6">
             <a:extLst>
               <a:ext uri="{FF2B5EF4-FFF2-40B4-BE49-F238E27FC236}">
-                <a16:creationId xmlns:a16="http://schemas.microsoft.com/office/drawing/2014/main" id="{3C320664-1A73-5709-0B8E-F6E5BC794337}"/>
+                <a16:creationId xmlns:a16="http://schemas.microsoft.com/office/drawing/2014/main" id="{1942AC02-4403-2FBE-1774-CCF0F8FE9EAD}"/>
               </a:ext>
             </a:extLst>
           </p:cNvPr>
@@ -2949,7 +2985,7 @@
           <a:bodyPr/>
           <a:lstStyle/>
           <a:p>
-            <a:fld id="{EE324605-CD83-4736-B4E3-14B7EC7E5F9E}" type="slidenum">
+            <a:fld id="{64C94B83-923C-44D9-A936-DC0156CB546B}" type="slidenum">
               <a:rPr lang="ko-KR" altLang="en-US" smtClean="0"/>
               <a:t>‹#›</a:t>
             </a:fld>
@@ -2960,7 +2996,7 @@
     </p:spTree>
     <p:extLst>
       <p:ext uri="{BB962C8B-B14F-4D97-AF65-F5344CB8AC3E}">
-        <p14:creationId xmlns:p14="http://schemas.microsoft.com/office/powerpoint/2010/main" val="99179130"/>
+        <p14:creationId xmlns:p14="http://schemas.microsoft.com/office/powerpoint/2010/main" val="4222793702"/>
       </p:ext>
     </p:extLst>
   </p:cSld>
@@ -2992,7 +3028,7 @@
           <p:cNvPr id="2" name="제목 1">
             <a:extLst>
               <a:ext uri="{FF2B5EF4-FFF2-40B4-BE49-F238E27FC236}">
-                <a16:creationId xmlns:a16="http://schemas.microsoft.com/office/drawing/2014/main" id="{672E0A02-FFAE-85D9-D2DB-C43BC5AAA36A}"/>
+                <a16:creationId xmlns:a16="http://schemas.microsoft.com/office/drawing/2014/main" id="{6A53542D-70D4-FB66-C4B1-04E59DED29CB}"/>
               </a:ext>
             </a:extLst>
           </p:cNvPr>
@@ -3029,7 +3065,7 @@
           <p:cNvPr id="3" name="그림 개체 틀 2">
             <a:extLst>
               <a:ext uri="{FF2B5EF4-FFF2-40B4-BE49-F238E27FC236}">
-                <a16:creationId xmlns:a16="http://schemas.microsoft.com/office/drawing/2014/main" id="{6C571F90-7212-34BA-C586-44AB5D0F9BF2}"/>
+                <a16:creationId xmlns:a16="http://schemas.microsoft.com/office/drawing/2014/main" id="{4EF8E8A6-802F-7861-14AE-2F1578CE35CA}"/>
               </a:ext>
             </a:extLst>
           </p:cNvPr>
@@ -3096,7 +3132,7 @@
           <p:cNvPr id="4" name="텍스트 개체 틀 3">
             <a:extLst>
               <a:ext uri="{FF2B5EF4-FFF2-40B4-BE49-F238E27FC236}">
-                <a16:creationId xmlns:a16="http://schemas.microsoft.com/office/drawing/2014/main" id="{AFE40B42-8FF9-3A81-E453-47D86F29E9FD}"/>
+                <a16:creationId xmlns:a16="http://schemas.microsoft.com/office/drawing/2014/main" id="{F6B8CA97-A61D-3A78-5B6C-033FB1DDFA9D}"/>
               </a:ext>
             </a:extLst>
           </p:cNvPr>
@@ -3167,7 +3203,7 @@
           <p:cNvPr id="5" name="날짜 개체 틀 4">
             <a:extLst>
               <a:ext uri="{FF2B5EF4-FFF2-40B4-BE49-F238E27FC236}">
-                <a16:creationId xmlns:a16="http://schemas.microsoft.com/office/drawing/2014/main" id="{A9566595-0612-A31F-BE09-978B42106F41}"/>
+                <a16:creationId xmlns:a16="http://schemas.microsoft.com/office/drawing/2014/main" id="{5C1A0B78-9508-D8FB-6402-88FDADCB7A87}"/>
               </a:ext>
             </a:extLst>
           </p:cNvPr>
@@ -3183,9 +3219,9 @@
           <a:bodyPr/>
           <a:lstStyle/>
           <a:p>
-            <a:fld id="{49DDEBD7-486B-43A9-948C-BB74824A90CF}" type="datetimeFigureOut">
+            <a:fld id="{E5D7FBEA-28E1-46BB-A59C-4B2C97545460}" type="datetimeFigureOut">
               <a:rPr lang="ko-KR" altLang="en-US" smtClean="0"/>
-              <a:t>2025-05-15</a:t>
+              <a:t>2025-05-21</a:t>
             </a:fld>
             <a:endParaRPr lang="ko-KR" altLang="en-US"/>
           </a:p>
@@ -3196,7 +3232,7 @@
           <p:cNvPr id="6" name="바닥글 개체 틀 5">
             <a:extLst>
               <a:ext uri="{FF2B5EF4-FFF2-40B4-BE49-F238E27FC236}">
-                <a16:creationId xmlns:a16="http://schemas.microsoft.com/office/drawing/2014/main" id="{357AB0FA-A5AF-C89F-6C36-C0599D328132}"/>
+                <a16:creationId xmlns:a16="http://schemas.microsoft.com/office/drawing/2014/main" id="{28AF7F11-850C-8729-7AD1-D98DC60B8F56}"/>
               </a:ext>
             </a:extLst>
           </p:cNvPr>
@@ -3221,7 +3257,7 @@
           <p:cNvPr id="7" name="슬라이드 번호 개체 틀 6">
             <a:extLst>
               <a:ext uri="{FF2B5EF4-FFF2-40B4-BE49-F238E27FC236}">
-                <a16:creationId xmlns:a16="http://schemas.microsoft.com/office/drawing/2014/main" id="{CBA8ECD2-3235-00D5-002B-743D8C6932D1}"/>
+                <a16:creationId xmlns:a16="http://schemas.microsoft.com/office/drawing/2014/main" id="{DFE05C8F-7D2E-2F9D-91F6-C798218EE3D5}"/>
               </a:ext>
             </a:extLst>
           </p:cNvPr>
@@ -3237,7 +3273,7 @@
           <a:bodyPr/>
           <a:lstStyle/>
           <a:p>
-            <a:fld id="{EE324605-CD83-4736-B4E3-14B7EC7E5F9E}" type="slidenum">
+            <a:fld id="{64C94B83-923C-44D9-A936-DC0156CB546B}" type="slidenum">
               <a:rPr lang="ko-KR" altLang="en-US" smtClean="0"/>
               <a:t>‹#›</a:t>
             </a:fld>
@@ -3248,7 +3284,7 @@
     </p:spTree>
     <p:extLst>
       <p:ext uri="{BB962C8B-B14F-4D97-AF65-F5344CB8AC3E}">
-        <p14:creationId xmlns:p14="http://schemas.microsoft.com/office/powerpoint/2010/main" val="214625262"/>
+        <p14:creationId xmlns:p14="http://schemas.microsoft.com/office/powerpoint/2010/main" val="4060076011"/>
       </p:ext>
     </p:extLst>
   </p:cSld>
@@ -3285,7 +3321,7 @@
           <p:cNvPr id="2" name="제목 개체 틀 1">
             <a:extLst>
               <a:ext uri="{FF2B5EF4-FFF2-40B4-BE49-F238E27FC236}">
-                <a16:creationId xmlns:a16="http://schemas.microsoft.com/office/drawing/2014/main" id="{E2870B12-0765-55BE-4A66-809C2DC4F93C}"/>
+                <a16:creationId xmlns:a16="http://schemas.microsoft.com/office/drawing/2014/main" id="{7AB3FCFA-8246-568F-AF4E-DA5707C6F08E}"/>
               </a:ext>
             </a:extLst>
           </p:cNvPr>
@@ -3323,7 +3359,7 @@
           <p:cNvPr id="3" name="텍스트 개체 틀 2">
             <a:extLst>
               <a:ext uri="{FF2B5EF4-FFF2-40B4-BE49-F238E27FC236}">
-                <a16:creationId xmlns:a16="http://schemas.microsoft.com/office/drawing/2014/main" id="{BEAB0AF1-4DDF-DF4B-DC05-548028B0BC0C}"/>
+                <a16:creationId xmlns:a16="http://schemas.microsoft.com/office/drawing/2014/main" id="{39F14F49-BED0-6E34-18B1-28B4486E6516}"/>
               </a:ext>
             </a:extLst>
           </p:cNvPr>
@@ -3390,7 +3426,7 @@
           <p:cNvPr id="4" name="날짜 개체 틀 3">
             <a:extLst>
               <a:ext uri="{FF2B5EF4-FFF2-40B4-BE49-F238E27FC236}">
-                <a16:creationId xmlns:a16="http://schemas.microsoft.com/office/drawing/2014/main" id="{2E5DE3EA-3009-5DEF-4B06-F743AACFD877}"/>
+                <a16:creationId xmlns:a16="http://schemas.microsoft.com/office/drawing/2014/main" id="{F21AB770-BE12-1056-AF0E-103D3C0F34C8}"/>
               </a:ext>
             </a:extLst>
           </p:cNvPr>
@@ -3424,9 +3460,9 @@
             </a:lvl1pPr>
           </a:lstStyle>
           <a:p>
-            <a:fld id="{49DDEBD7-486B-43A9-948C-BB74824A90CF}" type="datetimeFigureOut">
+            <a:fld id="{E5D7FBEA-28E1-46BB-A59C-4B2C97545460}" type="datetimeFigureOut">
               <a:rPr lang="ko-KR" altLang="en-US" smtClean="0"/>
-              <a:t>2025-05-15</a:t>
+              <a:t>2025-05-21</a:t>
             </a:fld>
             <a:endParaRPr lang="ko-KR" altLang="en-US"/>
           </a:p>
@@ -3437,7 +3473,7 @@
           <p:cNvPr id="5" name="바닥글 개체 틀 4">
             <a:extLst>
               <a:ext uri="{FF2B5EF4-FFF2-40B4-BE49-F238E27FC236}">
-                <a16:creationId xmlns:a16="http://schemas.microsoft.com/office/drawing/2014/main" id="{4EC09B4E-92A0-018A-96A1-A03933B9F185}"/>
+                <a16:creationId xmlns:a16="http://schemas.microsoft.com/office/drawing/2014/main" id="{17894AB2-CDE9-54E3-84DE-3CAAF667BF26}"/>
               </a:ext>
             </a:extLst>
           </p:cNvPr>
@@ -3480,7 +3516,7 @@
           <p:cNvPr id="6" name="슬라이드 번호 개체 틀 5">
             <a:extLst>
               <a:ext uri="{FF2B5EF4-FFF2-40B4-BE49-F238E27FC236}">
-                <a16:creationId xmlns:a16="http://schemas.microsoft.com/office/drawing/2014/main" id="{52DB232B-A2BC-CC70-03B4-3D5175DAC695}"/>
+                <a16:creationId xmlns:a16="http://schemas.microsoft.com/office/drawing/2014/main" id="{BE021E35-2A2D-83DA-0356-FA43910495B3}"/>
               </a:ext>
             </a:extLst>
           </p:cNvPr>
@@ -3514,7 +3550,7 @@
             </a:lvl1pPr>
           </a:lstStyle>
           <a:p>
-            <a:fld id="{EE324605-CD83-4736-B4E3-14B7EC7E5F9E}" type="slidenum">
+            <a:fld id="{64C94B83-923C-44D9-A936-DC0156CB546B}" type="slidenum">
               <a:rPr lang="ko-KR" altLang="en-US" smtClean="0"/>
               <a:t>‹#›</a:t>
             </a:fld>
@@ -3525,7 +3561,7 @@
     </p:spTree>
     <p:extLst>
       <p:ext uri="{BB962C8B-B14F-4D97-AF65-F5344CB8AC3E}">
-        <p14:creationId xmlns:p14="http://schemas.microsoft.com/office/powerpoint/2010/main" val="2768051632"/>
+        <p14:creationId xmlns:p14="http://schemas.microsoft.com/office/powerpoint/2010/main" val="1811367403"/>
       </p:ext>
     </p:extLst>
   </p:cSld>
@@ -3845,304 +3881,20 @@
       </p:grpSpPr>
       <p:sp>
         <p:nvSpPr>
-          <p:cNvPr id="2" name="제목 1">
-            <a:extLst>
-              <a:ext uri="{FF2B5EF4-FFF2-40B4-BE49-F238E27FC236}">
-                <a16:creationId xmlns:a16="http://schemas.microsoft.com/office/drawing/2014/main" id="{1B096BC9-5728-36C0-C0DA-A63AA86C0883}"/>
-              </a:ext>
-            </a:extLst>
-          </p:cNvPr>
-          <p:cNvSpPr>
-            <a:spLocks noGrp="1"/>
-          </p:cNvSpPr>
-          <p:nvPr>
-            <p:ph type="ctrTitle"/>
-          </p:nvPr>
+          <p:cNvPr id="7" name="직사각형 6">
+            <a:extLst>
+              <a:ext uri="{FF2B5EF4-FFF2-40B4-BE49-F238E27FC236}">
+                <a16:creationId xmlns:a16="http://schemas.microsoft.com/office/drawing/2014/main" id="{EAEA0AB2-A814-31B0-A48E-D611090EB99D}"/>
+              </a:ext>
+            </a:extLst>
+          </p:cNvPr>
+          <p:cNvSpPr/>
+          <p:nvPr/>
         </p:nvSpPr>
         <p:spPr>
           <a:xfrm>
-            <a:off x="1524000" y="1110861"/>
-            <a:ext cx="9144000" cy="2387600"/>
-          </a:xfrm>
-        </p:spPr>
-        <p:txBody>
-          <a:bodyPr/>
-          <a:lstStyle/>
-          <a:p>
-            <a:r>
-              <a:rPr lang="en-US" altLang="ko-KR"/>
-              <a:t>${PresentationTitle}</a:t>
-            </a:r>
-            <a:endParaRPr lang="ko-KR" altLang="en-US"/>
-          </a:p>
-        </p:txBody>
-      </p:sp>
-      <p:sp>
-        <p:nvSpPr>
-          <p:cNvPr id="3" name="부제목 2">
-            <a:extLst>
-              <a:ext uri="{FF2B5EF4-FFF2-40B4-BE49-F238E27FC236}">
-                <a16:creationId xmlns:a16="http://schemas.microsoft.com/office/drawing/2014/main" id="{B03DA0F9-11B4-C42B-8917-83766C693294}"/>
-              </a:ext>
-            </a:extLst>
-          </p:cNvPr>
-          <p:cNvSpPr>
-            <a:spLocks noGrp="1"/>
-          </p:cNvSpPr>
-          <p:nvPr>
-            <p:ph type="subTitle" idx="1"/>
-          </p:nvPr>
-        </p:nvSpPr>
-        <p:spPr>
-          <a:xfrm>
-            <a:off x="1524000" y="3590536"/>
-            <a:ext cx="9144000" cy="1655762"/>
-          </a:xfrm>
-        </p:spPr>
-        <p:txBody>
-          <a:bodyPr/>
-          <a:lstStyle/>
-          <a:p>
-            <a:r>
-              <a:rPr lang="en-US" altLang="ko-KR">
-                <a:solidFill>
-                  <a:schemeClr val="accent3"/>
-                </a:solidFill>
-              </a:rPr>
-              <a:t>${</a:t>
-            </a:r>
-            <a:r>
-              <a:rPr lang="en-US" altLang="ko-KR" u="sng">
-                <a:solidFill>
-                  <a:schemeClr val="accent3"/>
-                </a:solidFill>
-              </a:rPr>
-              <a:t>PresentationSubtitle</a:t>
-            </a:r>
-            <a:r>
-              <a:rPr lang="en-US" altLang="ko-KR">
-                <a:solidFill>
-                  <a:schemeClr val="accent3"/>
-                </a:solidFill>
-              </a:rPr>
-              <a:t>}</a:t>
-            </a:r>
-            <a:endParaRPr lang="ko-KR" altLang="en-US">
-              <a:solidFill>
-                <a:schemeClr val="accent3"/>
-              </a:solidFill>
-            </a:endParaRPr>
-          </a:p>
-        </p:txBody>
-      </p:sp>
-      <p:sp>
-        <p:nvSpPr>
-          <p:cNvPr id="4" name="직사각형 3">
-            <a:extLst>
-              <a:ext uri="{FF2B5EF4-FFF2-40B4-BE49-F238E27FC236}">
-                <a16:creationId xmlns:a16="http://schemas.microsoft.com/office/drawing/2014/main" id="{5E6C1D67-6E23-EA2D-DB25-825D2CA9338F}"/>
-              </a:ext>
-            </a:extLst>
-          </p:cNvPr>
-          <p:cNvSpPr/>
-          <p:nvPr/>
-        </p:nvSpPr>
-        <p:spPr>
-          <a:xfrm>
-            <a:off x="4882551" y="345057"/>
-            <a:ext cx="2426898" cy="2012830"/>
-          </a:xfrm>
-          <a:prstGeom prst="rect">
-            <a:avLst/>
-          </a:prstGeom>
-        </p:spPr>
-        <p:style>
-          <a:lnRef idx="2">
-            <a:schemeClr val="dk1"/>
-          </a:lnRef>
-          <a:fillRef idx="1">
-            <a:schemeClr val="lt1"/>
-          </a:fillRef>
-          <a:effectRef idx="0">
-            <a:schemeClr val="dk1"/>
-          </a:effectRef>
-          <a:fontRef idx="minor">
-            <a:schemeClr val="dk1"/>
-          </a:fontRef>
-        </p:style>
-        <p:txBody>
-          <a:bodyPr rtlCol="0" anchor="ctr"/>
-          <a:lstStyle/>
-          <a:p>
-            <a:pPr algn="ctr"/>
-            <a:r>
-              <a:rPr lang="en-US" altLang="ko-KR"/>
-              <a:t>${ppt.Image(LogoPath)}</a:t>
-            </a:r>
-            <a:endParaRPr lang="ko-KR" altLang="en-US"/>
-          </a:p>
-        </p:txBody>
-      </p:sp>
-      <p:sp>
-        <p:nvSpPr>
-          <p:cNvPr id="6" name="TextBox 5">
-            <a:extLst>
-              <a:ext uri="{FF2B5EF4-FFF2-40B4-BE49-F238E27FC236}">
-                <a16:creationId xmlns:a16="http://schemas.microsoft.com/office/drawing/2014/main" id="{9C6DA08B-8492-7F59-E8C1-162CC0F75229}"/>
-              </a:ext>
-            </a:extLst>
-          </p:cNvPr>
-          <p:cNvSpPr txBox="1"/>
-          <p:nvPr/>
-        </p:nvSpPr>
-        <p:spPr>
-          <a:xfrm>
-            <a:off x="3967439" y="5061632"/>
-            <a:ext cx="4257127" cy="369332"/>
-          </a:xfrm>
-          <a:prstGeom prst="rect">
-            <a:avLst/>
-          </a:prstGeom>
-          <a:noFill/>
-        </p:spPr>
-        <p:txBody>
-          <a:bodyPr wrap="none" rtlCol="0">
-            <a:spAutoFit/>
-          </a:bodyPr>
-          <a:lstStyle/>
-          <a:p>
-            <a:pPr algn="ctr"/>
-            <a:r>
-              <a:rPr lang="en-US" altLang="ko-KR" i="1"/>
-              <a:t>Created At: ${Date:yyyy</a:t>
-            </a:r>
-            <a:r>
-              <a:rPr lang="ko-KR" altLang="en-US" i="1"/>
-              <a:t>년 </a:t>
-            </a:r>
-            <a:r>
-              <a:rPr lang="en-US" altLang="ko-KR" i="1"/>
-              <a:t>MM</a:t>
-            </a:r>
-            <a:r>
-              <a:rPr lang="ko-KR" altLang="en-US" i="1"/>
-              <a:t>월 </a:t>
-            </a:r>
-            <a:r>
-              <a:rPr lang="en-US" altLang="ko-KR" i="1"/>
-              <a:t>dd</a:t>
-            </a:r>
-            <a:r>
-              <a:rPr lang="ko-KR" altLang="en-US" i="1"/>
-              <a:t>일</a:t>
-            </a:r>
-            <a:r>
-              <a:rPr lang="en-US" altLang="ko-KR" i="1"/>
-              <a:t>}</a:t>
-            </a:r>
-            <a:endParaRPr lang="ko-KR" altLang="en-US" i="1"/>
-          </a:p>
-        </p:txBody>
-      </p:sp>
-      <p:sp>
-        <p:nvSpPr>
-          <p:cNvPr id="7" name="TextBox 6">
-            <a:extLst>
-              <a:ext uri="{FF2B5EF4-FFF2-40B4-BE49-F238E27FC236}">
-                <a16:creationId xmlns:a16="http://schemas.microsoft.com/office/drawing/2014/main" id="{9DE8EF63-8F46-1A0D-B627-F9D40F016500}"/>
-              </a:ext>
-            </a:extLst>
-          </p:cNvPr>
-          <p:cNvSpPr txBox="1"/>
-          <p:nvPr/>
-        </p:nvSpPr>
-        <p:spPr>
-          <a:xfrm>
-            <a:off x="4453856" y="5562473"/>
-            <a:ext cx="3284297" cy="369332"/>
-          </a:xfrm>
-          <a:prstGeom prst="rect">
-            <a:avLst/>
-          </a:prstGeom>
-          <a:noFill/>
-        </p:spPr>
-        <p:txBody>
-          <a:bodyPr wrap="none" rtlCol="0">
-            <a:spAutoFit/>
-          </a:bodyPr>
-          <a:lstStyle/>
-          <a:p>
-            <a:pPr algn="ctr"/>
-            <a:r>
-              <a:rPr lang="en-US" altLang="ko-KR" b="1"/>
-              <a:t>${CompanyName} </a:t>
-            </a:r>
-            <a:r>
-              <a:rPr lang="en-US" altLang="ko-KR" i="1">
-                <a:solidFill>
-                  <a:schemeClr val="bg2">
-                    <a:lumMod val="75000"/>
-                  </a:schemeClr>
-                </a:solidFill>
-              </a:rPr>
-              <a:t>Company</a:t>
-            </a:r>
-            <a:endParaRPr lang="ko-KR" altLang="en-US" i="1">
-              <a:solidFill>
-                <a:schemeClr val="bg2">
-                  <a:lumMod val="75000"/>
-                </a:schemeClr>
-              </a:solidFill>
-            </a:endParaRPr>
-          </a:p>
-        </p:txBody>
-      </p:sp>
-    </p:spTree>
-    <p:extLst>
-      <p:ext uri="{BB962C8B-B14F-4D97-AF65-F5344CB8AC3E}">
-        <p14:creationId xmlns:p14="http://schemas.microsoft.com/office/powerpoint/2010/main" val="4198785319"/>
-      </p:ext>
-    </p:extLst>
-  </p:cSld>
-  <p:clrMapOvr>
-    <a:masterClrMapping/>
-  </p:clrMapOvr>
-</p:sld>
-</file>
-
-<file path=ppt/slides/slide2.xml><?xml version="1.0" encoding="utf-8"?>
-<p:sld xmlns:a="http://schemas.openxmlformats.org/drawingml/2006/main" xmlns:r="http://schemas.openxmlformats.org/officeDocument/2006/relationships" xmlns:p="http://schemas.openxmlformats.org/presentationml/2006/main">
-  <p:cSld>
-    <p:spTree>
-      <p:nvGrpSpPr>
-        <p:cNvPr id="1" name=""/>
-        <p:cNvGrpSpPr/>
-        <p:nvPr/>
-      </p:nvGrpSpPr>
-      <p:grpSpPr>
-        <a:xfrm>
-          <a:off x="0" y="0"/>
-          <a:ext cx="0" cy="0"/>
-          <a:chOff x="0" y="0"/>
-          <a:chExt cx="0" cy="0"/>
-        </a:xfrm>
-      </p:grpSpPr>
-      <p:sp>
-        <p:nvSpPr>
-          <p:cNvPr id="4" name="직사각형 3">
-            <a:extLst>
-              <a:ext uri="{FF2B5EF4-FFF2-40B4-BE49-F238E27FC236}">
-                <a16:creationId xmlns:a16="http://schemas.microsoft.com/office/drawing/2014/main" id="{6D100B18-EF80-D3DF-D970-2D2249AFFF5E}"/>
-              </a:ext>
-            </a:extLst>
-          </p:cNvPr>
-          <p:cNvSpPr/>
-          <p:nvPr/>
-        </p:nvSpPr>
-        <p:spPr>
-          <a:xfrm>
-            <a:off x="370937" y="293299"/>
-            <a:ext cx="7433094" cy="1063924"/>
+            <a:off x="805131" y="437072"/>
+            <a:ext cx="5929223" cy="3312543"/>
           </a:xfrm>
           <a:prstGeom prst="rect">
             <a:avLst/>
@@ -4170,149 +3922,47 @@
           <a:p>
             <a:pPr algn="ctr"/>
             <a:r>
-              <a:rPr lang="en-US" altLang="ko-KR"/>
-              <a:t>${Categories[0].Name}</a:t>
-            </a:r>
-            <a:endParaRPr lang="ko-KR" altLang="en-US"/>
-          </a:p>
-        </p:txBody>
-      </p:sp>
-      <p:sp>
-        <p:nvSpPr>
-          <p:cNvPr id="5" name="TextBox 4">
-            <a:extLst>
-              <a:ext uri="{FF2B5EF4-FFF2-40B4-BE49-F238E27FC236}">
-                <a16:creationId xmlns:a16="http://schemas.microsoft.com/office/drawing/2014/main" id="{869DF30E-2F71-B300-B0FC-4608BA020A49}"/>
-              </a:ext>
-            </a:extLst>
-          </p:cNvPr>
-          <p:cNvSpPr txBox="1"/>
-          <p:nvPr/>
-        </p:nvSpPr>
-        <p:spPr>
-          <a:xfrm>
-            <a:off x="370936" y="1679275"/>
-            <a:ext cx="7433094" cy="369332"/>
-          </a:xfrm>
-          <a:prstGeom prst="rect">
-            <a:avLst/>
-          </a:prstGeom>
-          <a:noFill/>
-        </p:spPr>
-        <p:txBody>
-          <a:bodyPr wrap="square" rtlCol="0">
-            <a:spAutoFit/>
-          </a:bodyPr>
-          <a:lstStyle/>
-          <a:p>
-            <a:r>
-              <a:rPr lang="en-US" altLang="ko-KR"/>
-              <a:t>${Categories[0].Description}</a:t>
-            </a:r>
-            <a:endParaRPr lang="ko-KR" altLang="en-US"/>
-          </a:p>
-        </p:txBody>
-      </p:sp>
-      <p:sp>
-        <p:nvSpPr>
-          <p:cNvPr id="6" name="직사각형 5">
-            <a:extLst>
-              <a:ext uri="{FF2B5EF4-FFF2-40B4-BE49-F238E27FC236}">
-                <a16:creationId xmlns:a16="http://schemas.microsoft.com/office/drawing/2014/main" id="{5957CE37-71BD-E1E5-8A46-B6797C51EEED}"/>
-              </a:ext>
-            </a:extLst>
-          </p:cNvPr>
-          <p:cNvSpPr/>
-          <p:nvPr/>
-        </p:nvSpPr>
-        <p:spPr>
-          <a:xfrm>
-            <a:off x="7982310" y="293299"/>
-            <a:ext cx="3945148" cy="2967486"/>
-          </a:xfrm>
-          <a:prstGeom prst="rect">
-            <a:avLst/>
-          </a:prstGeom>
-        </p:spPr>
-        <p:style>
-          <a:lnRef idx="2">
-            <a:schemeClr val="accent6"/>
-          </a:lnRef>
-          <a:fillRef idx="1">
-            <a:schemeClr val="lt1"/>
-          </a:fillRef>
-          <a:effectRef idx="0">
-            <a:schemeClr val="accent6"/>
-          </a:effectRef>
-          <a:fontRef idx="minor">
-            <a:schemeClr val="dk1"/>
-          </a:fontRef>
-        </p:style>
-        <p:txBody>
-          <a:bodyPr rtlCol="0" anchor="ctr"/>
-          <a:lstStyle/>
-          <a:p>
-            <a:pPr algn="ctr"/>
-            <a:r>
-              <a:rPr lang="fr-FR" altLang="ko-KR"/>
-              <a:t>${ppt.Image(Categories[0].ImageUrl)}</a:t>
-            </a:r>
-            <a:endParaRPr lang="ko-KR" altLang="en-US"/>
-          </a:p>
-        </p:txBody>
-      </p:sp>
-      <p:sp>
-        <p:nvSpPr>
-          <p:cNvPr id="7" name="직사각형 6">
-            <a:extLst>
-              <a:ext uri="{FF2B5EF4-FFF2-40B4-BE49-F238E27FC236}">
-                <a16:creationId xmlns:a16="http://schemas.microsoft.com/office/drawing/2014/main" id="{19F15D03-4740-62FA-F247-0CD1EA1FFAD0}"/>
-              </a:ext>
-            </a:extLst>
-          </p:cNvPr>
-          <p:cNvSpPr/>
-          <p:nvPr/>
-        </p:nvSpPr>
-        <p:spPr>
-          <a:xfrm>
-            <a:off x="10811774" y="5664679"/>
-            <a:ext cx="1115684" cy="948906"/>
-          </a:xfrm>
-          <a:prstGeom prst="rect">
-            <a:avLst/>
-          </a:prstGeom>
-        </p:spPr>
-        <p:style>
-          <a:lnRef idx="2">
-            <a:schemeClr val="accent5"/>
-          </a:lnRef>
-          <a:fillRef idx="1">
-            <a:schemeClr val="lt1"/>
-          </a:fillRef>
-          <a:effectRef idx="0">
-            <a:schemeClr val="accent5"/>
-          </a:effectRef>
-          <a:fontRef idx="minor">
-            <a:schemeClr val="dk1"/>
-          </a:fontRef>
-        </p:style>
-        <p:txBody>
-          <a:bodyPr rtlCol="0" anchor="ctr"/>
-          <a:lstStyle/>
-          <a:p>
-            <a:pPr algn="ctr"/>
-            <a:r>
-              <a:rPr lang="en-US" altLang="ko-KR"/>
-              <a:t>${ppt.Image(LogoPath)}</a:t>
-            </a:r>
-            <a:endParaRPr lang="ko-KR" altLang="en-US"/>
+              <a:rPr lang="en-US" altLang="ko-KR" b="1">
+                <a:solidFill>
+                  <a:schemeClr val="accent4">
+                    <a:lumMod val="20000"/>
+                    <a:lumOff val="80000"/>
+                  </a:schemeClr>
+                </a:solidFill>
+                <a:highlight>
+                  <a:srgbClr val="000000"/>
+                </a:highlight>
+              </a:rPr>
+              <a:t>Hello</a:t>
+            </a:r>
+            <a:r>
+              <a:rPr lang="ko-KR" altLang="en-US"/>
+              <a:t> </a:t>
+            </a:r>
+            <a:r>
+              <a:rPr lang="en-US" altLang="ko-KR" i="1"/>
+              <a:t>${Categories[0].Name} </a:t>
+            </a:r>
+            <a:r>
+              <a:rPr lang="en-US" altLang="ko-KR" sz="1200">
+                <a:solidFill>
+                  <a:schemeClr val="accent2"/>
+                </a:solidFill>
+              </a:rPr>
+              <a:t>World</a:t>
+            </a:r>
+            <a:endParaRPr lang="ko-KR" altLang="en-US">
+              <a:solidFill>
+                <a:schemeClr val="accent2"/>
+              </a:solidFill>
+            </a:endParaRPr>
           </a:p>
         </p:txBody>
       </p:sp>
     </p:spTree>
     <p:extLst>
       <p:ext uri="{BB962C8B-B14F-4D97-AF65-F5344CB8AC3E}">
-        <p14:creationId xmlns:p14="http://schemas.microsoft.com/office/powerpoint/2010/main" val="3650587864"/>
+        <p14:creationId xmlns:p14="http://schemas.microsoft.com/office/powerpoint/2010/main" val="1779185163"/>
       </p:ext>
     </p:extLst>
   </p:cSld>
@@ -4322,12 +3972,18 @@
 </p:sld>
 </file>
 
-<file path=ppt/slides/slide3.xml><?xml version="1.0" encoding="utf-8"?>
+<file path=ppt/slides/slide2.xml><?xml version="1.0" encoding="utf-8"?>
 <p:sld xmlns:a="http://schemas.openxmlformats.org/drawingml/2006/main" xmlns:r="http://schemas.openxmlformats.org/officeDocument/2006/relationships" xmlns:p="http://schemas.openxmlformats.org/presentationml/2006/main">
   <p:cSld>
     <p:spTree>
       <p:nvGrpSpPr>
-        <p:cNvPr id="1" name=""/>
+        <p:cNvPr id="1" name="">
+          <a:extLst>
+            <a:ext uri="{FF2B5EF4-FFF2-40B4-BE49-F238E27FC236}">
+              <a16:creationId xmlns:a16="http://schemas.microsoft.com/office/drawing/2014/main" id="{69B37675-71B7-F2E6-03FB-1A7AE3FFFCCE}"/>
+            </a:ext>
+          </a:extLst>
+        </p:cNvPr>
         <p:cNvGrpSpPr/>
         <p:nvPr/>
       </p:nvGrpSpPr>
@@ -4341,10 +3997,10 @@
       </p:grpSpPr>
       <p:sp>
         <p:nvSpPr>
-          <p:cNvPr id="4" name="직사각형 3">
-            <a:extLst>
-              <a:ext uri="{FF2B5EF4-FFF2-40B4-BE49-F238E27FC236}">
-                <a16:creationId xmlns:a16="http://schemas.microsoft.com/office/drawing/2014/main" id="{3E182D44-9763-F473-DBE4-E6D8ED32D6CF}"/>
+          <p:cNvPr id="7" name="직사각형 6">
+            <a:extLst>
+              <a:ext uri="{FF2B5EF4-FFF2-40B4-BE49-F238E27FC236}">
+                <a16:creationId xmlns:a16="http://schemas.microsoft.com/office/drawing/2014/main" id="{62982A1C-83BD-4AA4-32C7-AB05F52821E2}"/>
               </a:ext>
             </a:extLst>
           </p:cNvPr>
@@ -4353,8 +4009,8 @@
         </p:nvSpPr>
         <p:spPr>
           <a:xfrm>
-            <a:off x="370937" y="293299"/>
-            <a:ext cx="11435750" cy="1063924"/>
+            <a:off x="2743200" y="971910"/>
+            <a:ext cx="8166341" cy="1282460"/>
           </a:xfrm>
           <a:prstGeom prst="rect">
             <a:avLst/>
@@ -4383,18 +4039,30 @@
             <a:pPr algn="ctr"/>
             <a:r>
               <a:rPr lang="en-US" altLang="ko-KR"/>
-              <a:t>${Categories_Name}</a:t>
-            </a:r>
-            <a:endParaRPr lang="ko-KR" altLang="en-US"/>
-          </a:p>
-        </p:txBody>
-      </p:sp>
-      <p:sp>
-        <p:nvSpPr>
-          <p:cNvPr id="5" name="직사각형 4">
-            <a:extLst>
-              <a:ext uri="{FF2B5EF4-FFF2-40B4-BE49-F238E27FC236}">
-                <a16:creationId xmlns:a16="http://schemas.microsoft.com/office/drawing/2014/main" id="{6E28CC0F-B9DF-3445-7982-2DCA9A6FACFC}"/>
+              <a:t>Hello: ${Categories&gt;Products[0].Name} </a:t>
+            </a:r>
+            <a:r>
+              <a:rPr lang="en-US" altLang="ko-KR" b="1">
+                <a:highlight>
+                  <a:srgbClr val="000000"/>
+                </a:highlight>
+              </a:rPr>
+              <a:t>WELCOME!!</a:t>
+            </a:r>
+            <a:endParaRPr lang="ko-KR" altLang="en-US" b="1">
+              <a:highlight>
+                <a:srgbClr val="000000"/>
+              </a:highlight>
+            </a:endParaRPr>
+          </a:p>
+        </p:txBody>
+      </p:sp>
+      <p:sp>
+        <p:nvSpPr>
+          <p:cNvPr id="4" name="직사각형 3">
+            <a:extLst>
+              <a:ext uri="{FF2B5EF4-FFF2-40B4-BE49-F238E27FC236}">
+                <a16:creationId xmlns:a16="http://schemas.microsoft.com/office/drawing/2014/main" id="{23F8A6D5-DC84-1169-F170-E2961632A923}"/>
               </a:ext>
             </a:extLst>
           </p:cNvPr>
@@ -4403,8 +4071,8 @@
         </p:nvSpPr>
         <p:spPr>
           <a:xfrm>
-            <a:off x="1886311" y="1708029"/>
-            <a:ext cx="6962722" cy="1063924"/>
+            <a:off x="2743199" y="3004869"/>
+            <a:ext cx="8166341" cy="1282460"/>
           </a:xfrm>
           <a:prstGeom prst="rect">
             <a:avLst/>
@@ -4412,43 +4080,84 @@
         </p:spPr>
         <p:style>
           <a:lnRef idx="2">
-            <a:schemeClr val="dk1"/>
+            <a:schemeClr val="accent1">
+              <a:shade val="15000"/>
+            </a:schemeClr>
           </a:lnRef>
           <a:fillRef idx="1">
-            <a:schemeClr val="lt1"/>
+            <a:schemeClr val="accent1"/>
           </a:fillRef>
           <a:effectRef idx="0">
-            <a:schemeClr val="dk1"/>
+            <a:schemeClr val="accent1"/>
           </a:effectRef>
           <a:fontRef idx="minor">
-            <a:schemeClr val="dk1"/>
+            <a:schemeClr val="lt1"/>
           </a:fontRef>
         </p:style>
         <p:txBody>
           <a:bodyPr rtlCol="0" anchor="ctr"/>
           <a:lstStyle/>
           <a:p>
-            <a:r>
-              <a:rPr lang="en-US" altLang="ko-KR" b="1"/>
-              <a:t>${Categories_Products[0].Name}</a:t>
-            </a:r>
-            <a:br>
-              <a:rPr lang="en-US" altLang="ko-KR"/>
-            </a:br>
-            <a:r>
-              <a:rPr lang="en-US" altLang="ko-KR" sz="1100" i="1"/>
-              <a:t>${Categories_Products[0].Description}</a:t>
-            </a:r>
-            <a:endParaRPr lang="ko-KR" altLang="en-US" i="1"/>
-          </a:p>
-        </p:txBody>
-      </p:sp>
-      <p:sp>
-        <p:nvSpPr>
-          <p:cNvPr id="10" name="직사각형 9">
-            <a:extLst>
-              <a:ext uri="{FF2B5EF4-FFF2-40B4-BE49-F238E27FC236}">
-                <a16:creationId xmlns:a16="http://schemas.microsoft.com/office/drawing/2014/main" id="{57FDFA41-224D-1040-5782-08930258F2C8}"/>
+            <a:pPr algn="ctr"/>
+            <a:r>
+              <a:rPr lang="en-US" altLang="ko-KR" sz="1400">
+                <a:solidFill>
+                  <a:schemeClr val="accent6">
+                    <a:lumMod val="40000"/>
+                    <a:lumOff val="60000"/>
+                  </a:schemeClr>
+                </a:solidFill>
+                <a:highlight>
+                  <a:srgbClr val="000000"/>
+                </a:highlight>
+              </a:rPr>
+              <a:t>~~ </a:t>
+            </a:r>
+            <a:r>
+              <a:rPr lang="en-US" altLang="ko-KR" sz="1400">
+                <a:solidFill>
+                  <a:schemeClr val="accent6">
+                    <a:lumMod val="40000"/>
+                    <a:lumOff val="60000"/>
+                  </a:schemeClr>
+                </a:solidFill>
+              </a:rPr>
+              <a:t>${Categories&gt;Products[1].Name}</a:t>
+            </a:r>
+            <a:r>
+              <a:rPr lang="en-US" altLang="ko-KR" sz="1400">
+                <a:solidFill>
+                  <a:schemeClr val="accent6">
+                    <a:lumMod val="40000"/>
+                    <a:lumOff val="60000"/>
+                  </a:schemeClr>
+                </a:solidFill>
+                <a:highlight>
+                  <a:srgbClr val="000000"/>
+                </a:highlight>
+              </a:rPr>
+              <a:t> ~~</a:t>
+            </a:r>
+            <a:endParaRPr lang="ko-KR" altLang="en-US" sz="1400">
+              <a:solidFill>
+                <a:schemeClr val="accent6">
+                  <a:lumMod val="40000"/>
+                  <a:lumOff val="60000"/>
+                </a:schemeClr>
+              </a:solidFill>
+              <a:highlight>
+                <a:srgbClr val="000000"/>
+              </a:highlight>
+            </a:endParaRPr>
+          </a:p>
+        </p:txBody>
+      </p:sp>
+      <p:sp>
+        <p:nvSpPr>
+          <p:cNvPr id="3" name="직사각형 2">
+            <a:extLst>
+              <a:ext uri="{FF2B5EF4-FFF2-40B4-BE49-F238E27FC236}">
+                <a16:creationId xmlns:a16="http://schemas.microsoft.com/office/drawing/2014/main" id="{1CB7A625-EC4E-4AAB-1BFC-A674C227D335}"/>
               </a:ext>
             </a:extLst>
           </p:cNvPr>
@@ -4457,8 +4166,8 @@
         </p:nvSpPr>
         <p:spPr>
           <a:xfrm>
-            <a:off x="385314" y="1708029"/>
-            <a:ext cx="1276710" cy="1063924"/>
+            <a:off x="902897" y="971910"/>
+            <a:ext cx="1616016" cy="1282460"/>
           </a:xfrm>
           <a:prstGeom prst="rect">
             <a:avLst/>
@@ -4466,13 +4175,13 @@
         </p:spPr>
         <p:style>
           <a:lnRef idx="2">
-            <a:schemeClr val="dk1"/>
+            <a:schemeClr val="accent6"/>
           </a:lnRef>
           <a:fillRef idx="1">
             <a:schemeClr val="lt1"/>
           </a:fillRef>
           <a:effectRef idx="0">
-            <a:schemeClr val="dk1"/>
+            <a:schemeClr val="accent6"/>
           </a:effectRef>
           <a:fontRef idx="minor">
             <a:schemeClr val="dk1"/>
@@ -4484,66 +4193,29 @@
           <a:p>
             <a:pPr algn="ctr"/>
             <a:r>
-              <a:rPr lang="en-US" altLang="ko-KR" sz="1100"/>
-              <a:t>${ppt.Image(Categories_Products[0].ImageUrl)}</a:t>
-            </a:r>
-            <a:endParaRPr lang="ko-KR" altLang="en-US" sz="1100"/>
-          </a:p>
-        </p:txBody>
-      </p:sp>
-      <p:sp>
-        <p:nvSpPr>
-          <p:cNvPr id="13" name="TextBox 12">
-            <a:extLst>
-              <a:ext uri="{FF2B5EF4-FFF2-40B4-BE49-F238E27FC236}">
-                <a16:creationId xmlns:a16="http://schemas.microsoft.com/office/drawing/2014/main" id="{0BB0406A-C40B-A843-E893-7EC1021F8B11}"/>
-              </a:ext>
-            </a:extLst>
-          </p:cNvPr>
-          <p:cNvSpPr txBox="1"/>
+              <a:rPr lang="en-US" altLang="ko-KR" sz="1000"/>
+              <a:t>${ppt.Image(Categories&gt;Products[0].Url)}</a:t>
+            </a:r>
+            <a:endParaRPr lang="ko-KR" altLang="en-US" sz="1000"/>
+          </a:p>
+        </p:txBody>
+      </p:sp>
+      <p:sp>
+        <p:nvSpPr>
+          <p:cNvPr id="5" name="직사각형 4">
+            <a:extLst>
+              <a:ext uri="{FF2B5EF4-FFF2-40B4-BE49-F238E27FC236}">
+                <a16:creationId xmlns:a16="http://schemas.microsoft.com/office/drawing/2014/main" id="{3615E91E-2457-0C42-D548-DACFD17144CE}"/>
+              </a:ext>
+            </a:extLst>
+          </p:cNvPr>
+          <p:cNvSpPr/>
           <p:nvPr/>
         </p:nvSpPr>
         <p:spPr>
           <a:xfrm>
-            <a:off x="7852397" y="2002231"/>
-            <a:ext cx="3954289" cy="369332"/>
-          </a:xfrm>
-          <a:prstGeom prst="rect">
-            <a:avLst/>
-          </a:prstGeom>
-          <a:noFill/>
-        </p:spPr>
-        <p:txBody>
-          <a:bodyPr wrap="none" rtlCol="0">
-            <a:spAutoFit/>
-          </a:bodyPr>
-          <a:lstStyle/>
-          <a:p>
-            <a:pPr algn="r"/>
-            <a:r>
-              <a:rPr lang="en-US" altLang="ko-KR" b="1"/>
-              <a:t>${Categories_Products[0].Price:C2}</a:t>
-            </a:r>
-            <a:endParaRPr lang="ko-KR" altLang="en-US" b="1"/>
-          </a:p>
-        </p:txBody>
-      </p:sp>
-      <p:sp>
-        <p:nvSpPr>
-          <p:cNvPr id="14" name="직사각형 13">
-            <a:extLst>
-              <a:ext uri="{FF2B5EF4-FFF2-40B4-BE49-F238E27FC236}">
-                <a16:creationId xmlns:a16="http://schemas.microsoft.com/office/drawing/2014/main" id="{16A99439-0C55-0C41-BDC3-3576532174F4}"/>
-              </a:ext>
-            </a:extLst>
-          </p:cNvPr>
-          <p:cNvSpPr/>
-          <p:nvPr/>
-        </p:nvSpPr>
-        <p:spPr>
-          <a:xfrm>
-            <a:off x="1886311" y="3311670"/>
-            <a:ext cx="6962722" cy="1063924"/>
+            <a:off x="902897" y="3004869"/>
+            <a:ext cx="1616016" cy="1282460"/>
           </a:xfrm>
           <a:prstGeom prst="rect">
             <a:avLst/>
@@ -4551,13 +4223,13 @@
         </p:spPr>
         <p:style>
           <a:lnRef idx="2">
-            <a:schemeClr val="dk1"/>
+            <a:schemeClr val="accent6"/>
           </a:lnRef>
           <a:fillRef idx="1">
             <a:schemeClr val="lt1"/>
           </a:fillRef>
           <a:effectRef idx="0">
-            <a:schemeClr val="dk1"/>
+            <a:schemeClr val="accent6"/>
           </a:effectRef>
           <a:fontRef idx="minor">
             <a:schemeClr val="dk1"/>
@@ -4567,249 +4239,19 @@
           <a:bodyPr rtlCol="0" anchor="ctr"/>
           <a:lstStyle/>
           <a:p>
-            <a:r>
-              <a:rPr lang="en-US" altLang="ko-KR" b="1"/>
-              <a:t>${Categories_Products[1].Name}</a:t>
-            </a:r>
-            <a:br>
-              <a:rPr lang="en-US" altLang="ko-KR"/>
-            </a:br>
-            <a:r>
-              <a:rPr lang="en-US" altLang="ko-KR" sz="1100" i="1"/>
-              <a:t>${Categories_Products[1].Description}</a:t>
-            </a:r>
-            <a:endParaRPr lang="ko-KR" altLang="en-US" i="1"/>
-          </a:p>
-        </p:txBody>
-      </p:sp>
-      <p:sp>
-        <p:nvSpPr>
-          <p:cNvPr id="15" name="직사각형 14">
-            <a:extLst>
-              <a:ext uri="{FF2B5EF4-FFF2-40B4-BE49-F238E27FC236}">
-                <a16:creationId xmlns:a16="http://schemas.microsoft.com/office/drawing/2014/main" id="{86547F4E-74D6-CFE4-4247-2F8581565938}"/>
-              </a:ext>
-            </a:extLst>
-          </p:cNvPr>
-          <p:cNvSpPr/>
-          <p:nvPr/>
-        </p:nvSpPr>
-        <p:spPr>
-          <a:xfrm>
-            <a:off x="385314" y="3311670"/>
-            <a:ext cx="1276710" cy="1063924"/>
-          </a:xfrm>
-          <a:prstGeom prst="rect">
-            <a:avLst/>
-          </a:prstGeom>
-        </p:spPr>
-        <p:style>
-          <a:lnRef idx="2">
-            <a:schemeClr val="dk1"/>
-          </a:lnRef>
-          <a:fillRef idx="1">
-            <a:schemeClr val="lt1"/>
-          </a:fillRef>
-          <a:effectRef idx="0">
-            <a:schemeClr val="dk1"/>
-          </a:effectRef>
-          <a:fontRef idx="minor">
-            <a:schemeClr val="dk1"/>
-          </a:fontRef>
-        </p:style>
-        <p:txBody>
-          <a:bodyPr rtlCol="0" anchor="ctr"/>
-          <a:lstStyle/>
-          <a:p>
             <a:pPr algn="ctr"/>
             <a:r>
-              <a:rPr lang="en-US" altLang="ko-KR" sz="1100"/>
-              <a:t>${ppt.Image(Categories_Products[1].ImageUrl)}</a:t>
-            </a:r>
-            <a:endParaRPr lang="ko-KR" altLang="en-US" sz="1100"/>
-          </a:p>
-        </p:txBody>
-      </p:sp>
-      <p:sp>
-        <p:nvSpPr>
-          <p:cNvPr id="16" name="TextBox 15">
-            <a:extLst>
-              <a:ext uri="{FF2B5EF4-FFF2-40B4-BE49-F238E27FC236}">
-                <a16:creationId xmlns:a16="http://schemas.microsoft.com/office/drawing/2014/main" id="{8E31634D-F9E3-E11D-5B95-2EAC6F02F7B7}"/>
-              </a:ext>
-            </a:extLst>
-          </p:cNvPr>
-          <p:cNvSpPr txBox="1"/>
-          <p:nvPr/>
-        </p:nvSpPr>
-        <p:spPr>
-          <a:xfrm>
-            <a:off x="7852397" y="3605872"/>
-            <a:ext cx="3954289" cy="369332"/>
-          </a:xfrm>
-          <a:prstGeom prst="rect">
-            <a:avLst/>
-          </a:prstGeom>
-          <a:noFill/>
-        </p:spPr>
-        <p:txBody>
-          <a:bodyPr wrap="none" rtlCol="0">
-            <a:spAutoFit/>
-          </a:bodyPr>
-          <a:lstStyle/>
-          <a:p>
-            <a:pPr algn="r"/>
-            <a:r>
-              <a:rPr lang="en-US" altLang="ko-KR" b="1"/>
-              <a:t>${Categories_Products[1].Price:C2}</a:t>
-            </a:r>
-            <a:endParaRPr lang="ko-KR" altLang="en-US" b="1"/>
-          </a:p>
-        </p:txBody>
-      </p:sp>
-      <p:sp>
-        <p:nvSpPr>
-          <p:cNvPr id="17" name="직사각형 16">
-            <a:extLst>
-              <a:ext uri="{FF2B5EF4-FFF2-40B4-BE49-F238E27FC236}">
-                <a16:creationId xmlns:a16="http://schemas.microsoft.com/office/drawing/2014/main" id="{4FCBDF13-348C-00B3-BDB3-75D55E81723A}"/>
-              </a:ext>
-            </a:extLst>
-          </p:cNvPr>
-          <p:cNvSpPr/>
-          <p:nvPr/>
-        </p:nvSpPr>
-        <p:spPr>
-          <a:xfrm>
-            <a:off x="1886311" y="4915311"/>
-            <a:ext cx="6962722" cy="1063924"/>
-          </a:xfrm>
-          <a:prstGeom prst="rect">
-            <a:avLst/>
-          </a:prstGeom>
-        </p:spPr>
-        <p:style>
-          <a:lnRef idx="2">
-            <a:schemeClr val="dk1"/>
-          </a:lnRef>
-          <a:fillRef idx="1">
-            <a:schemeClr val="lt1"/>
-          </a:fillRef>
-          <a:effectRef idx="0">
-            <a:schemeClr val="dk1"/>
-          </a:effectRef>
-          <a:fontRef idx="minor">
-            <a:schemeClr val="dk1"/>
-          </a:fontRef>
-        </p:style>
-        <p:txBody>
-          <a:bodyPr rtlCol="0" anchor="ctr"/>
-          <a:lstStyle/>
-          <a:p>
-            <a:r>
-              <a:rPr lang="en-US" altLang="ko-KR" b="1"/>
-              <a:t>${Categories_Products[2].Name}</a:t>
-            </a:r>
-            <a:br>
-              <a:rPr lang="en-US" altLang="ko-KR"/>
-            </a:br>
-            <a:r>
-              <a:rPr lang="en-US" altLang="ko-KR" sz="1100" i="1"/>
-              <a:t>${Categories_Products[2].Description}</a:t>
-            </a:r>
-            <a:endParaRPr lang="ko-KR" altLang="en-US" i="1"/>
-          </a:p>
-        </p:txBody>
-      </p:sp>
-      <p:sp>
-        <p:nvSpPr>
-          <p:cNvPr id="18" name="직사각형 17">
-            <a:extLst>
-              <a:ext uri="{FF2B5EF4-FFF2-40B4-BE49-F238E27FC236}">
-                <a16:creationId xmlns:a16="http://schemas.microsoft.com/office/drawing/2014/main" id="{F1FB2613-4FA4-F5EE-4E0F-885999A3D24F}"/>
-              </a:ext>
-            </a:extLst>
-          </p:cNvPr>
-          <p:cNvSpPr/>
-          <p:nvPr/>
-        </p:nvSpPr>
-        <p:spPr>
-          <a:xfrm>
-            <a:off x="385314" y="4915311"/>
-            <a:ext cx="1276710" cy="1063924"/>
-          </a:xfrm>
-          <a:prstGeom prst="rect">
-            <a:avLst/>
-          </a:prstGeom>
-        </p:spPr>
-        <p:style>
-          <a:lnRef idx="2">
-            <a:schemeClr val="dk1"/>
-          </a:lnRef>
-          <a:fillRef idx="1">
-            <a:schemeClr val="lt1"/>
-          </a:fillRef>
-          <a:effectRef idx="0">
-            <a:schemeClr val="dk1"/>
-          </a:effectRef>
-          <a:fontRef idx="minor">
-            <a:schemeClr val="dk1"/>
-          </a:fontRef>
-        </p:style>
-        <p:txBody>
-          <a:bodyPr rtlCol="0" anchor="ctr"/>
-          <a:lstStyle/>
-          <a:p>
-            <a:pPr algn="ctr"/>
-            <a:r>
-              <a:rPr lang="en-US" altLang="ko-KR" sz="1100"/>
-              <a:t>${ppt.Image(Categories_Products[2].ImageUrl)}</a:t>
-            </a:r>
-            <a:endParaRPr lang="ko-KR" altLang="en-US" sz="1100"/>
-          </a:p>
-        </p:txBody>
-      </p:sp>
-      <p:sp>
-        <p:nvSpPr>
-          <p:cNvPr id="19" name="TextBox 18">
-            <a:extLst>
-              <a:ext uri="{FF2B5EF4-FFF2-40B4-BE49-F238E27FC236}">
-                <a16:creationId xmlns:a16="http://schemas.microsoft.com/office/drawing/2014/main" id="{FB18109B-EED7-8727-5CEF-C2CF88D8733C}"/>
-              </a:ext>
-            </a:extLst>
-          </p:cNvPr>
-          <p:cNvSpPr txBox="1"/>
-          <p:nvPr/>
-        </p:nvSpPr>
-        <p:spPr>
-          <a:xfrm>
-            <a:off x="7852397" y="5209513"/>
-            <a:ext cx="3954289" cy="369332"/>
-          </a:xfrm>
-          <a:prstGeom prst="rect">
-            <a:avLst/>
-          </a:prstGeom>
-          <a:noFill/>
-        </p:spPr>
-        <p:txBody>
-          <a:bodyPr wrap="none" rtlCol="0">
-            <a:spAutoFit/>
-          </a:bodyPr>
-          <a:lstStyle/>
-          <a:p>
-            <a:pPr algn="r"/>
-            <a:r>
-              <a:rPr lang="en-US" altLang="ko-KR" b="1"/>
-              <a:t>${Categories_Products[2].Price:C2}</a:t>
-            </a:r>
-            <a:endParaRPr lang="ko-KR" altLang="en-US" b="1"/>
+              <a:rPr lang="en-US" altLang="ko-KR" sz="1000"/>
+              <a:t>${ppt.Image(Categories&gt;Products[1].Url)}</a:t>
+            </a:r>
+            <a:endParaRPr lang="ko-KR" altLang="en-US" sz="1000"/>
           </a:p>
         </p:txBody>
       </p:sp>
     </p:spTree>
     <p:extLst>
       <p:ext uri="{BB962C8B-B14F-4D97-AF65-F5344CB8AC3E}">
-        <p14:creationId xmlns:p14="http://schemas.microsoft.com/office/powerpoint/2010/main" val="1701855880"/>
+        <p14:creationId xmlns:p14="http://schemas.microsoft.com/office/powerpoint/2010/main" val="2062894524"/>
       </p:ext>
     </p:extLst>
   </p:cSld>

</xml_diff>